<commit_message>
feat: enhance slide management with notes slide handling and validation improvements
</commit_message>
<xml_diff>
--- a/tests/fixtures/sample.pptx
+++ b/tests/fixtures/sample.pptx
@@ -4,10 +4,16 @@
   <p:sldMasterIdLst>
     <p:sldMasterId id="2147483648" r:id="rId1"/>
   </p:sldMasterIdLst>
+  <p:notesMasterIdLst>
+    <p:notesMasterId r:id="rId8"/>
+  </p:notesMasterIdLst>
   <p:sldIdLst>
     <p:sldId id="256" r:id="rId2"/>
     <p:sldId id="257" r:id="rId3"/>
     <p:sldId id="258" r:id="rId4"/>
+    <p:sldId id="259" r:id="rId5"/>
+    <p:sldId id="260" r:id="rId6"/>
+    <p:sldId id="261" r:id="rId7"/>
   </p:sldIdLst>
   <p:sldSz cx="12192000" cy="6858000"/>
   <p:notesSz cx="6858000" cy="9144000"/>
@@ -118,6 +124,9 @@
         <p14:section name="Untitled Section" id="{A3775758-1637-48C8-9754-A5DF8ED68B74}">
           <p14:sldIdLst>
             <p14:sldId id="258"/>
+            <p14:sldId id="259"/>
+            <p14:sldId id="260"/>
+            <p14:sldId id="261"/>
           </p14:sldIdLst>
         </p14:section>
       </p14:sectionLst>
@@ -127,6 +136,15 @@
     </p:ext>
   </p:extLst>
 </p:presentation>
+</file>
+
+<file path=ppt/revisionInfo.xml><?xml version="1.0" encoding="utf-8"?>
+<p1510:revInfo xmlns:a="http://schemas.openxmlformats.org/drawingml/2006/main" xmlns:r="http://schemas.openxmlformats.org/officeDocument/2006/relationships" xmlns:p1510="http://schemas.microsoft.com/office/powerpoint/2015/10/main">
+  <p1510:revLst>
+    <p1510:client id="{00C3C471-C754-871F-AF6C-A200F7425B03}" v="122" dt="2026-06-18T11:32:04.302"/>
+    <p1510:client id="{2796ABAA-F5FB-42ED-8CAB-0587183265E4}" v="9" dt="2026-06-18T08:43:12.964"/>
+  </p1510:revLst>
+</p1510:revInfo>
 </file>
 
 <file path=ppt/charts/chart1.xml><?xml version="1.0" encoding="utf-8"?>
@@ -144,6 +162,46 @@
   </mc:AlternateContent>
   <c:chart>
     <c:title>
+      <c:tx>
+        <c:rich>
+          <a:bodyPr rot="0" spcFirstLastPara="1" vertOverflow="ellipsis" vert="horz" wrap="square" anchor="ctr" anchorCtr="1"/>
+          <a:lstStyle/>
+          <a:p>
+            <a:pPr algn="r">
+              <a:defRPr sz="3200" b="0" i="0" u="none" strike="noStrike" kern="1200" spc="0" baseline="0">
+                <a:solidFill>
+                  <a:schemeClr val="tx1">
+                    <a:lumMod val="65000"/>
+                    <a:lumOff val="35000"/>
+                  </a:schemeClr>
+                </a:solidFill>
+                <a:latin typeface="Algerian" panose="04020705040A02060702" pitchFamily="82" charset="0"/>
+                <a:ea typeface="+mn-ea"/>
+                <a:cs typeface="+mn-cs"/>
+              </a:defRPr>
+            </a:pPr>
+            <a:r>
+              <a:rPr lang="en-IN" sz="3200" b="0">
+                <a:latin typeface="Algerian" panose="04020705040A02060702" pitchFamily="82" charset="0"/>
+              </a:rPr>
+              <a:t>Chart</a:t>
+            </a:r>
+          </a:p>
+          <a:p>
+            <a:pPr algn="r">
+              <a:defRPr sz="3200">
+                <a:latin typeface="Algerian" panose="04020705040A02060702" pitchFamily="82" charset="0"/>
+              </a:defRPr>
+            </a:pPr>
+            <a:r>
+              <a:rPr lang="en-IN" sz="1800" b="1">
+                <a:latin typeface="Agency FB" panose="020B0503020202020204" pitchFamily="34" charset="0"/>
+              </a:rPr>
+              <a:t>Title</a:t>
+            </a:r>
+          </a:p>
+        </c:rich>
+      </c:tx>
       <c:overlay val="0"/>
       <c:spPr>
         <a:noFill/>
@@ -156,15 +214,15 @@
         <a:bodyPr rot="0" spcFirstLastPara="1" vertOverflow="ellipsis" vert="horz" wrap="square" anchor="ctr" anchorCtr="1"/>
         <a:lstStyle/>
         <a:p>
-          <a:pPr>
-            <a:defRPr sz="1862" b="0" i="0" u="none" strike="noStrike" kern="1200" spc="0" baseline="0">
+          <a:pPr algn="r">
+            <a:defRPr sz="3200" b="0" i="0" u="none" strike="noStrike" kern="1200" spc="0" baseline="0">
               <a:solidFill>
                 <a:schemeClr val="tx1">
                   <a:lumMod val="65000"/>
                   <a:lumOff val="35000"/>
                 </a:schemeClr>
               </a:solidFill>
-              <a:latin typeface="+mn-lt"/>
+              <a:latin typeface="Algerian" panose="04020705040A02060702" pitchFamily="82" charset="0"/>
               <a:ea typeface="+mn-ea"/>
               <a:cs typeface="+mn-cs"/>
             </a:defRPr>
@@ -204,6 +262,64 @@
             <a:effectLst/>
           </c:spPr>
           <c:invertIfNegative val="0"/>
+          <c:dLbls>
+            <c:spPr>
+              <a:noFill/>
+              <a:ln>
+                <a:noFill/>
+              </a:ln>
+              <a:effectLst/>
+            </c:spPr>
+            <c:txPr>
+              <a:bodyPr rot="0" spcFirstLastPara="1" vertOverflow="ellipsis" vert="horz" wrap="square" lIns="38100" tIns="19050" rIns="38100" bIns="19050" anchor="ctr" anchorCtr="1">
+                <a:spAutoFit/>
+              </a:bodyPr>
+              <a:lstStyle/>
+              <a:p>
+                <a:pPr>
+                  <a:defRPr sz="2400" b="0" i="0" u="none" strike="noStrike" kern="1200" baseline="0">
+                    <a:solidFill>
+                      <a:schemeClr val="tx1">
+                        <a:lumMod val="75000"/>
+                        <a:lumOff val="25000"/>
+                      </a:schemeClr>
+                    </a:solidFill>
+                    <a:latin typeface="Adobe Garamond Pro Bold" panose="02020702060506020403" pitchFamily="18" charset="0"/>
+                    <a:ea typeface="+mn-ea"/>
+                    <a:cs typeface="+mn-cs"/>
+                  </a:defRPr>
+                </a:pPr>
+                <a:endParaRPr lang="en-US"/>
+              </a:p>
+            </c:txPr>
+            <c:dLblPos val="outEnd"/>
+            <c:showLegendKey val="0"/>
+            <c:showVal val="1"/>
+            <c:showCatName val="0"/>
+            <c:showSerName val="0"/>
+            <c:showPercent val="0"/>
+            <c:showBubbleSize val="0"/>
+            <c:showLeaderLines val="0"/>
+            <c:extLst>
+              <c:ext xmlns:c15="http://schemas.microsoft.com/office/drawing/2012/chart" uri="{CE6537A1-D6FC-4f65-9D91-7224C49458BB}">
+                <c15:showLeaderLines val="1"/>
+                <c15:leaderLines>
+                  <c:spPr>
+                    <a:ln w="9525" cap="flat" cmpd="sng" algn="ctr">
+                      <a:solidFill>
+                        <a:schemeClr val="tx1">
+                          <a:lumMod val="35000"/>
+                          <a:lumOff val="65000"/>
+                        </a:schemeClr>
+                      </a:solidFill>
+                      <a:round/>
+                    </a:ln>
+                    <a:effectLst/>
+                  </c:spPr>
+                </c15:leaderLines>
+              </c:ext>
+            </c:extLst>
+          </c:dLbls>
           <c:cat>
             <c:strRef>
               <c:f>Sheet1!$A$2:$A$5</c:f>
@@ -275,6 +391,64 @@
             <a:effectLst/>
           </c:spPr>
           <c:invertIfNegative val="0"/>
+          <c:dLbls>
+            <c:spPr>
+              <a:noFill/>
+              <a:ln>
+                <a:noFill/>
+              </a:ln>
+              <a:effectLst/>
+            </c:spPr>
+            <c:txPr>
+              <a:bodyPr rot="0" spcFirstLastPara="1" vertOverflow="ellipsis" vert="horz" wrap="square" lIns="38100" tIns="19050" rIns="38100" bIns="19050" anchor="ctr" anchorCtr="1">
+                <a:spAutoFit/>
+              </a:bodyPr>
+              <a:lstStyle/>
+              <a:p>
+                <a:pPr>
+                  <a:defRPr sz="1197" b="0" i="0" u="none" strike="noStrike" kern="1200" baseline="0">
+                    <a:solidFill>
+                      <a:schemeClr val="tx1">
+                        <a:lumMod val="75000"/>
+                        <a:lumOff val="25000"/>
+                      </a:schemeClr>
+                    </a:solidFill>
+                    <a:latin typeface="+mn-lt"/>
+                    <a:ea typeface="+mn-ea"/>
+                    <a:cs typeface="+mn-cs"/>
+                  </a:defRPr>
+                </a:pPr>
+                <a:endParaRPr lang="en-US"/>
+              </a:p>
+            </c:txPr>
+            <c:dLblPos val="outEnd"/>
+            <c:showLegendKey val="0"/>
+            <c:showVal val="1"/>
+            <c:showCatName val="0"/>
+            <c:showSerName val="0"/>
+            <c:showPercent val="0"/>
+            <c:showBubbleSize val="0"/>
+            <c:showLeaderLines val="0"/>
+            <c:extLst>
+              <c:ext xmlns:c15="http://schemas.microsoft.com/office/drawing/2012/chart" uri="{CE6537A1-D6FC-4f65-9D91-7224C49458BB}">
+                <c15:showLeaderLines val="1"/>
+                <c15:leaderLines>
+                  <c:spPr>
+                    <a:ln w="9525" cap="flat" cmpd="sng" algn="ctr">
+                      <a:solidFill>
+                        <a:schemeClr val="tx1">
+                          <a:lumMod val="35000"/>
+                          <a:lumOff val="65000"/>
+                        </a:schemeClr>
+                      </a:solidFill>
+                      <a:round/>
+                    </a:ln>
+                    <a:effectLst/>
+                  </c:spPr>
+                </c15:leaderLines>
+              </c:ext>
+            </c:extLst>
+          </c:dLbls>
           <c:cat>
             <c:strRef>
               <c:f>Sheet1!$A$2:$A$5</c:f>
@@ -338,7 +512,7 @@
           </c:tx>
           <c:spPr>
             <a:solidFill>
-              <a:schemeClr val="accent3"/>
+              <a:schemeClr val="accent6"/>
             </a:solidFill>
             <a:ln>
               <a:noFill/>
@@ -346,6 +520,64 @@
             <a:effectLst/>
           </c:spPr>
           <c:invertIfNegative val="0"/>
+          <c:dLbls>
+            <c:spPr>
+              <a:noFill/>
+              <a:ln>
+                <a:noFill/>
+              </a:ln>
+              <a:effectLst/>
+            </c:spPr>
+            <c:txPr>
+              <a:bodyPr rot="0" spcFirstLastPara="1" vertOverflow="ellipsis" vert="horz" wrap="square" lIns="38100" tIns="19050" rIns="38100" bIns="19050" anchor="ctr" anchorCtr="1">
+                <a:spAutoFit/>
+              </a:bodyPr>
+              <a:lstStyle/>
+              <a:p>
+                <a:pPr>
+                  <a:defRPr sz="1197" b="0" i="0" u="none" strike="noStrike" kern="1200" baseline="0">
+                    <a:solidFill>
+                      <a:schemeClr val="tx1">
+                        <a:lumMod val="75000"/>
+                        <a:lumOff val="25000"/>
+                      </a:schemeClr>
+                    </a:solidFill>
+                    <a:latin typeface="+mn-lt"/>
+                    <a:ea typeface="+mn-ea"/>
+                    <a:cs typeface="+mn-cs"/>
+                  </a:defRPr>
+                </a:pPr>
+                <a:endParaRPr lang="en-US"/>
+              </a:p>
+            </c:txPr>
+            <c:dLblPos val="outEnd"/>
+            <c:showLegendKey val="0"/>
+            <c:showVal val="1"/>
+            <c:showCatName val="0"/>
+            <c:showSerName val="0"/>
+            <c:showPercent val="0"/>
+            <c:showBubbleSize val="0"/>
+            <c:showLeaderLines val="0"/>
+            <c:extLst>
+              <c:ext xmlns:c15="http://schemas.microsoft.com/office/drawing/2012/chart" uri="{CE6537A1-D6FC-4f65-9D91-7224C49458BB}">
+                <c15:showLeaderLines val="1"/>
+                <c15:leaderLines>
+                  <c:spPr>
+                    <a:ln w="9525" cap="flat" cmpd="sng" algn="ctr">
+                      <a:solidFill>
+                        <a:schemeClr val="tx1">
+                          <a:lumMod val="35000"/>
+                          <a:lumOff val="65000"/>
+                        </a:schemeClr>
+                      </a:solidFill>
+                      <a:round/>
+                    </a:ln>
+                    <a:effectLst/>
+                  </c:spPr>
+                </c15:leaderLines>
+              </c:ext>
+            </c:extLst>
+          </c:dLbls>
           <c:cat>
             <c:strRef>
               <c:f>Sheet1!$A$2:$A$5</c:f>
@@ -394,8 +626,9 @@
           </c:extLst>
         </c:ser>
         <c:dLbls>
+          <c:dLblPos val="outEnd"/>
           <c:showLegendKey val="0"/>
-          <c:showVal val="0"/>
+          <c:showVal val="1"/>
           <c:showCatName val="0"/>
           <c:showSerName val="0"/>
           <c:showPercent val="0"/>
@@ -1043,6 +1276,800 @@
 </c:chartSpace>
 </file>
 
+<file path=ppt/charts/chart3.xml><?xml version="1.0" encoding="utf-8"?>
+<c:chartSpace xmlns:c="http://schemas.openxmlformats.org/drawingml/2006/chart" xmlns:a="http://schemas.openxmlformats.org/drawingml/2006/main" xmlns:r="http://schemas.openxmlformats.org/officeDocument/2006/relationships" xmlns:c16r2="http://schemas.microsoft.com/office/drawing/2015/06/chart">
+  <c:date1904 val="0"/>
+  <c:lang val="en-US"/>
+  <c:roundedCorners val="0"/>
+  <mc:AlternateContent xmlns:mc="http://schemas.openxmlformats.org/markup-compatibility/2006">
+    <mc:Choice xmlns:c14="http://schemas.microsoft.com/office/drawing/2007/8/2/chart" Requires="c14">
+      <c14:style val="102"/>
+    </mc:Choice>
+    <mc:Fallback>
+      <c:style val="2"/>
+    </mc:Fallback>
+  </mc:AlternateContent>
+  <c:chart>
+    <c:autoTitleDeleted val="0"/>
+    <c:plotArea>
+      <c:layout>
+        <c:manualLayout>
+          <c:layoutTarget val="inner"/>
+          <c:xMode val="edge"/>
+          <c:yMode val="edge"/>
+          <c:x val="1.2077294685990338E-2"/>
+          <c:y val="4.793028322440087E-2"/>
+          <c:w val="0.97342995169082125"/>
+          <c:h val="0.95206971677559915"/>
+        </c:manualLayout>
+      </c:layout>
+      <c:barChart>
+        <c:barDir val="col"/>
+        <c:grouping val="stacked"/>
+        <c:varyColors val="0"/>
+        <c:ser>
+          <c:idx val="0"/>
+          <c:order val="0"/>
+          <c:tx>
+            <c:strRef>
+              <c:f>Sheet1!$B$1</c:f>
+              <c:strCache>
+                <c:ptCount val="1"/>
+                <c:pt idx="0">
+                  <c:v>Series 1</c:v>
+                </c:pt>
+              </c:strCache>
+            </c:strRef>
+          </c:tx>
+          <c:spPr>
+            <a:solidFill>
+              <a:schemeClr val="accent1"/>
+            </a:solidFill>
+            <a:ln>
+              <a:noFill/>
+            </a:ln>
+            <a:effectLst/>
+          </c:spPr>
+          <c:invertIfNegative val="0"/>
+          <c:dLbls>
+            <c:dLbl>
+              <c:idx val="0"/>
+              <c:layout>
+                <c:manualLayout>
+                  <c:x val="0.19082125603864733"/>
+                  <c:y val="-0.12636165577342057"/>
+                </c:manualLayout>
+              </c:layout>
+              <c:spPr>
+                <a:solidFill>
+                  <a:srgbClr val="4472C4"/>
+                </a:solidFill>
+                <a:ln>
+                  <a:noFill/>
+                </a:ln>
+                <a:effectLst/>
+              </c:spPr>
+              <c:txPr>
+                <a:bodyPr rot="0" spcFirstLastPara="1" vertOverflow="ellipsis" vert="horz" wrap="square" lIns="38100" tIns="19050" rIns="38100" bIns="19050" anchor="ctr" anchorCtr="0">
+                  <a:noAutofit/>
+                </a:bodyPr>
+                <a:lstStyle/>
+                <a:p>
+                  <a:pPr algn="ctr">
+                    <a:defRPr lang="en-US" sz="1800" b="0" i="0" u="none" strike="noStrike" kern="1200" baseline="0">
+                      <a:solidFill>
+                        <a:schemeClr val="bg1"/>
+                      </a:solidFill>
+                      <a:latin typeface="+mn-lt"/>
+                      <a:ea typeface="+mn-ea"/>
+                      <a:cs typeface="+mn-cs"/>
+                    </a:defRPr>
+                  </a:pPr>
+                  <a:endParaRPr lang="en-US"/>
+                </a:p>
+              </c:txPr>
+              <c:dLblPos val="ctr"/>
+              <c:showLegendKey val="0"/>
+              <c:showVal val="1"/>
+              <c:showCatName val="0"/>
+              <c:showSerName val="0"/>
+              <c:showPercent val="0"/>
+              <c:showBubbleSize val="0"/>
+              <c:extLst>
+                <c:ext xmlns:c15="http://schemas.microsoft.com/office/drawing/2012/chart" uri="{CE6537A1-D6FC-4f65-9D91-7224C49458BB}">
+                  <c15:layout>
+                    <c:manualLayout>
+                      <c:w val="6.6177583780288332E-2"/>
+                      <c:h val="8.4912939804093132E-2"/>
+                    </c:manualLayout>
+                  </c15:layout>
+                </c:ext>
+                <c:ext xmlns:c16="http://schemas.microsoft.com/office/drawing/2014/chart" uri="{C3380CC4-5D6E-409C-BE32-E72D297353CC}">
+                  <c16:uniqueId val="{00000001-C41C-4F54-805C-4E5E94C272C8}"/>
+                </c:ext>
+              </c:extLst>
+            </c:dLbl>
+            <c:spPr>
+              <a:solidFill>
+                <a:srgbClr val="4472C4"/>
+              </a:solidFill>
+              <a:ln>
+                <a:noFill/>
+              </a:ln>
+              <a:effectLst/>
+            </c:spPr>
+            <c:txPr>
+              <a:bodyPr rot="0" spcFirstLastPara="1" vertOverflow="ellipsis" vert="horz" wrap="square" lIns="38100" tIns="19050" rIns="38100" bIns="19050" anchor="ctr" anchorCtr="0">
+                <a:spAutoFit/>
+              </a:bodyPr>
+              <a:lstStyle/>
+              <a:p>
+                <a:pPr algn="ctr">
+                  <a:defRPr lang="en-US" sz="8000" b="0" i="0" u="none" strike="noStrike" kern="1200" baseline="0">
+                    <a:solidFill>
+                      <a:schemeClr val="bg1"/>
+                    </a:solidFill>
+                    <a:latin typeface="+mn-lt"/>
+                    <a:ea typeface="+mn-ea"/>
+                    <a:cs typeface="+mn-cs"/>
+                  </a:defRPr>
+                </a:pPr>
+                <a:endParaRPr lang="en-US"/>
+              </a:p>
+            </c:txPr>
+            <c:dLblPos val="ctr"/>
+            <c:showLegendKey val="0"/>
+            <c:showVal val="1"/>
+            <c:showCatName val="0"/>
+            <c:showSerName val="0"/>
+            <c:showPercent val="0"/>
+            <c:showBubbleSize val="0"/>
+            <c:showLeaderLines val="0"/>
+            <c:extLst>
+              <c:ext xmlns:c15="http://schemas.microsoft.com/office/drawing/2012/chart" uri="{CE6537A1-D6FC-4f65-9D91-7224C49458BB}">
+                <c15:showLeaderLines val="1"/>
+                <c15:leaderLines>
+                  <c:spPr>
+                    <a:ln w="9525" cap="flat" cmpd="sng" algn="ctr">
+                      <a:solidFill>
+                        <a:schemeClr val="tx1">
+                          <a:lumMod val="35000"/>
+                          <a:lumOff val="65000"/>
+                        </a:schemeClr>
+                      </a:solidFill>
+                      <a:round/>
+                    </a:ln>
+                    <a:effectLst/>
+                  </c:spPr>
+                </c15:leaderLines>
+              </c:ext>
+            </c:extLst>
+          </c:dLbls>
+          <c:cat>
+            <c:strRef>
+              <c:f>Sheet1!$A$2</c:f>
+              <c:strCache>
+                <c:ptCount val="1"/>
+                <c:pt idx="0">
+                  <c:v>Category 1</c:v>
+                </c:pt>
+              </c:strCache>
+            </c:strRef>
+          </c:cat>
+          <c:val>
+            <c:numRef>
+              <c:f>Sheet1!$B$2</c:f>
+              <c:numCache>
+                <c:formatCode>General</c:formatCode>
+                <c:ptCount val="1"/>
+                <c:pt idx="0">
+                  <c:v>4.3</c:v>
+                </c:pt>
+              </c:numCache>
+            </c:numRef>
+          </c:val>
+          <c:extLst>
+            <c:ext xmlns:c16="http://schemas.microsoft.com/office/drawing/2014/chart" uri="{C3380CC4-5D6E-409C-BE32-E72D297353CC}">
+              <c16:uniqueId val="{00000000-9D08-4425-99DE-4E5501F36EC7}"/>
+            </c:ext>
+          </c:extLst>
+        </c:ser>
+        <c:ser>
+          <c:idx val="1"/>
+          <c:order val="1"/>
+          <c:tx>
+            <c:strRef>
+              <c:f>Sheet1!$C$1</c:f>
+              <c:strCache>
+                <c:ptCount val="1"/>
+                <c:pt idx="0">
+                  <c:v>Series 2</c:v>
+                </c:pt>
+              </c:strCache>
+            </c:strRef>
+          </c:tx>
+          <c:spPr>
+            <a:solidFill>
+              <a:schemeClr val="accent2"/>
+            </a:solidFill>
+            <a:ln>
+              <a:noFill/>
+            </a:ln>
+            <a:effectLst/>
+          </c:spPr>
+          <c:invertIfNegative val="0"/>
+          <c:dLbls>
+            <c:dLbl>
+              <c:idx val="0"/>
+              <c:layout>
+                <c:manualLayout>
+                  <c:x val="0.19444444444444445"/>
+                  <c:y val="-5.4466230936819175E-2"/>
+                </c:manualLayout>
+              </c:layout>
+              <c:spPr>
+                <a:solidFill>
+                  <a:srgbClr val="ED7D31"/>
+                </a:solidFill>
+                <a:ln>
+                  <a:noFill/>
+                </a:ln>
+                <a:effectLst/>
+              </c:spPr>
+              <c:txPr>
+                <a:bodyPr rot="0" spcFirstLastPara="1" vertOverflow="ellipsis" vert="horz" wrap="square" lIns="38100" tIns="19050" rIns="38100" bIns="19050" anchor="ctr" anchorCtr="0">
+                  <a:noAutofit/>
+                </a:bodyPr>
+                <a:lstStyle/>
+                <a:p>
+                  <a:pPr algn="ctr">
+                    <a:defRPr lang="en-US" sz="1800" b="0" i="0" u="none" strike="noStrike" kern="1200" baseline="0">
+                      <a:solidFill>
+                        <a:schemeClr val="bg1"/>
+                      </a:solidFill>
+                      <a:latin typeface="+mn-lt"/>
+                      <a:ea typeface="+mn-ea"/>
+                      <a:cs typeface="+mn-cs"/>
+                    </a:defRPr>
+                  </a:pPr>
+                  <a:endParaRPr lang="en-US"/>
+                </a:p>
+              </c:txPr>
+              <c:dLblPos val="ctr"/>
+              <c:showLegendKey val="0"/>
+              <c:showVal val="1"/>
+              <c:showCatName val="0"/>
+              <c:showSerName val="0"/>
+              <c:showPercent val="0"/>
+              <c:showBubbleSize val="0"/>
+              <c:extLst>
+                <c:ext xmlns:c15="http://schemas.microsoft.com/office/drawing/2012/chart" uri="{CE6537A1-D6FC-4f65-9D91-7224C49458BB}">
+                  <c15:layout>
+                    <c:manualLayout>
+                      <c:w val="7.7047148997679643E-2"/>
+                      <c:h val="9.7984835228929715E-2"/>
+                    </c:manualLayout>
+                  </c15:layout>
+                </c:ext>
+                <c:ext xmlns:c16="http://schemas.microsoft.com/office/drawing/2014/chart" uri="{C3380CC4-5D6E-409C-BE32-E72D297353CC}">
+                  <c16:uniqueId val="{00000002-4D89-4FC3-BEAD-7878BEFDFFA6}"/>
+                </c:ext>
+              </c:extLst>
+            </c:dLbl>
+            <c:spPr>
+              <a:solidFill>
+                <a:srgbClr val="ED7D31"/>
+              </a:solidFill>
+              <a:ln>
+                <a:noFill/>
+              </a:ln>
+              <a:effectLst/>
+            </c:spPr>
+            <c:txPr>
+              <a:bodyPr rot="0" spcFirstLastPara="1" vertOverflow="ellipsis" vert="horz" wrap="square" lIns="38100" tIns="19050" rIns="38100" bIns="19050" anchor="ctr" anchorCtr="0">
+                <a:spAutoFit/>
+              </a:bodyPr>
+              <a:lstStyle/>
+              <a:p>
+                <a:pPr algn="ctr">
+                  <a:defRPr lang="en-US" sz="8000" b="0" i="0" u="none" strike="noStrike" kern="1200" baseline="0">
+                    <a:solidFill>
+                      <a:schemeClr val="tx1">
+                        <a:lumMod val="75000"/>
+                        <a:lumOff val="25000"/>
+                      </a:schemeClr>
+                    </a:solidFill>
+                    <a:latin typeface="+mn-lt"/>
+                    <a:ea typeface="+mn-ea"/>
+                    <a:cs typeface="+mn-cs"/>
+                  </a:defRPr>
+                </a:pPr>
+                <a:endParaRPr lang="en-US"/>
+              </a:p>
+            </c:txPr>
+            <c:dLblPos val="ctr"/>
+            <c:showLegendKey val="0"/>
+            <c:showVal val="1"/>
+            <c:showCatName val="0"/>
+            <c:showSerName val="0"/>
+            <c:showPercent val="0"/>
+            <c:showBubbleSize val="0"/>
+            <c:showLeaderLines val="0"/>
+            <c:extLst>
+              <c:ext xmlns:c15="http://schemas.microsoft.com/office/drawing/2012/chart" uri="{CE6537A1-D6FC-4f65-9D91-7224C49458BB}">
+                <c15:showLeaderLines val="1"/>
+                <c15:leaderLines>
+                  <c:spPr>
+                    <a:ln w="9525" cap="flat" cmpd="sng" algn="ctr">
+                      <a:solidFill>
+                        <a:schemeClr val="tx1">
+                          <a:lumMod val="35000"/>
+                          <a:lumOff val="65000"/>
+                        </a:schemeClr>
+                      </a:solidFill>
+                      <a:round/>
+                    </a:ln>
+                    <a:effectLst/>
+                  </c:spPr>
+                </c15:leaderLines>
+              </c:ext>
+            </c:extLst>
+          </c:dLbls>
+          <c:cat>
+            <c:strRef>
+              <c:f>Sheet1!$A$2</c:f>
+              <c:strCache>
+                <c:ptCount val="1"/>
+                <c:pt idx="0">
+                  <c:v>Category 1</c:v>
+                </c:pt>
+              </c:strCache>
+            </c:strRef>
+          </c:cat>
+          <c:val>
+            <c:numRef>
+              <c:f>Sheet1!$C$2</c:f>
+              <c:numCache>
+                <c:formatCode>General</c:formatCode>
+                <c:ptCount val="1"/>
+                <c:pt idx="0">
+                  <c:v>2.5</c:v>
+                </c:pt>
+              </c:numCache>
+            </c:numRef>
+          </c:val>
+          <c:extLst>
+            <c:ext xmlns:c16="http://schemas.microsoft.com/office/drawing/2014/chart" uri="{C3380CC4-5D6E-409C-BE32-E72D297353CC}">
+              <c16:uniqueId val="{00000003-9D08-4425-99DE-4E5501F36EC7}"/>
+            </c:ext>
+          </c:extLst>
+        </c:ser>
+        <c:ser>
+          <c:idx val="2"/>
+          <c:order val="2"/>
+          <c:tx>
+            <c:strRef>
+              <c:f>Sheet1!$D$1</c:f>
+              <c:strCache>
+                <c:ptCount val="1"/>
+                <c:pt idx="0">
+                  <c:v>Series 3</c:v>
+                </c:pt>
+              </c:strCache>
+            </c:strRef>
+          </c:tx>
+          <c:spPr>
+            <a:solidFill>
+              <a:schemeClr val="accent3"/>
+            </a:solidFill>
+            <a:ln>
+              <a:noFill/>
+            </a:ln>
+            <a:effectLst/>
+          </c:spPr>
+          <c:invertIfNegative val="0"/>
+          <c:dLbls>
+            <c:dLbl>
+              <c:idx val="0"/>
+              <c:layout>
+                <c:manualLayout>
+                  <c:x val="0.27777777777777779"/>
+                  <c:y val="-7.6252723311546866E-2"/>
+                </c:manualLayout>
+              </c:layout>
+              <c:spPr>
+                <a:solidFill>
+                  <a:srgbClr val="A5A5A5"/>
+                </a:solidFill>
+                <a:ln>
+                  <a:noFill/>
+                </a:ln>
+                <a:effectLst/>
+              </c:spPr>
+              <c:txPr>
+                <a:bodyPr rot="0" spcFirstLastPara="1" vertOverflow="ellipsis" vert="horz" wrap="square" lIns="38100" tIns="19050" rIns="38100" bIns="19050" anchor="ctr" anchorCtr="0">
+                  <a:noAutofit/>
+                </a:bodyPr>
+                <a:lstStyle/>
+                <a:p>
+                  <a:pPr algn="ctr">
+                    <a:defRPr lang="en-US" sz="1800" b="0" i="0" u="none" strike="noStrike" kern="1200" baseline="0">
+                      <a:solidFill>
+                        <a:schemeClr val="bg1"/>
+                      </a:solidFill>
+                      <a:latin typeface="+mn-lt"/>
+                      <a:ea typeface="+mn-ea"/>
+                      <a:cs typeface="+mn-cs"/>
+                    </a:defRPr>
+                  </a:pPr>
+                  <a:endParaRPr lang="en-US"/>
+                </a:p>
+              </c:txPr>
+              <c:dLblPos val="ctr"/>
+              <c:showLegendKey val="0"/>
+              <c:showVal val="1"/>
+              <c:showCatName val="0"/>
+              <c:showSerName val="0"/>
+              <c:showPercent val="0"/>
+              <c:showBubbleSize val="0"/>
+              <c:extLst>
+                <c:ext xmlns:c15="http://schemas.microsoft.com/office/drawing/2012/chart" uri="{CE6537A1-D6FC-4f65-9D91-7224C49458BB}">
+                  <c15:layout>
+                    <c:manualLayout>
+                      <c:w val="0.23405197991555404"/>
+                      <c:h val="0.16552296159058552"/>
+                    </c:manualLayout>
+                  </c15:layout>
+                </c:ext>
+                <c:ext xmlns:c16="http://schemas.microsoft.com/office/drawing/2014/chart" uri="{C3380CC4-5D6E-409C-BE32-E72D297353CC}">
+                  <c16:uniqueId val="{00000003-4D89-4FC3-BEAD-7878BEFDFFA6}"/>
+                </c:ext>
+              </c:extLst>
+            </c:dLbl>
+            <c:spPr>
+              <a:solidFill>
+                <a:srgbClr val="A5A5A5"/>
+              </a:solidFill>
+              <a:ln>
+                <a:noFill/>
+              </a:ln>
+              <a:effectLst/>
+            </c:spPr>
+            <c:txPr>
+              <a:bodyPr rot="0" spcFirstLastPara="1" vertOverflow="ellipsis" vert="horz" wrap="square" lIns="38100" tIns="19050" rIns="38100" bIns="19050" anchor="ctr" anchorCtr="0">
+                <a:spAutoFit/>
+              </a:bodyPr>
+              <a:lstStyle/>
+              <a:p>
+                <a:pPr algn="ctr">
+                  <a:defRPr lang="en-US" sz="8000" b="0" i="0" u="none" strike="noStrike" kern="1200" baseline="0">
+                    <a:solidFill>
+                      <a:schemeClr val="tx1">
+                        <a:lumMod val="75000"/>
+                        <a:lumOff val="25000"/>
+                      </a:schemeClr>
+                    </a:solidFill>
+                    <a:latin typeface="+mn-lt"/>
+                    <a:ea typeface="+mn-ea"/>
+                    <a:cs typeface="+mn-cs"/>
+                  </a:defRPr>
+                </a:pPr>
+                <a:endParaRPr lang="en-US"/>
+              </a:p>
+            </c:txPr>
+            <c:dLblPos val="ctr"/>
+            <c:showLegendKey val="0"/>
+            <c:showVal val="1"/>
+            <c:showCatName val="0"/>
+            <c:showSerName val="0"/>
+            <c:showPercent val="0"/>
+            <c:showBubbleSize val="0"/>
+            <c:showLeaderLines val="0"/>
+            <c:extLst>
+              <c:ext xmlns:c15="http://schemas.microsoft.com/office/drawing/2012/chart" uri="{CE6537A1-D6FC-4f65-9D91-7224C49458BB}">
+                <c15:showLeaderLines val="1"/>
+                <c15:leaderLines>
+                  <c:spPr>
+                    <a:ln w="9525" cap="flat" cmpd="sng" algn="ctr">
+                      <a:solidFill>
+                        <a:schemeClr val="tx1">
+                          <a:lumMod val="35000"/>
+                          <a:lumOff val="65000"/>
+                        </a:schemeClr>
+                      </a:solidFill>
+                      <a:round/>
+                    </a:ln>
+                    <a:effectLst/>
+                  </c:spPr>
+                </c15:leaderLines>
+              </c:ext>
+            </c:extLst>
+          </c:dLbls>
+          <c:cat>
+            <c:strRef>
+              <c:f>Sheet1!$A$2</c:f>
+              <c:strCache>
+                <c:ptCount val="1"/>
+                <c:pt idx="0">
+                  <c:v>Category 1</c:v>
+                </c:pt>
+              </c:strCache>
+            </c:strRef>
+          </c:cat>
+          <c:val>
+            <c:numRef>
+              <c:f>Sheet1!$D$2</c:f>
+              <c:numCache>
+                <c:formatCode>General</c:formatCode>
+                <c:ptCount val="1"/>
+                <c:pt idx="0">
+                  <c:v>3.5</c:v>
+                </c:pt>
+              </c:numCache>
+            </c:numRef>
+          </c:val>
+          <c:extLst>
+            <c:ext xmlns:c16="http://schemas.microsoft.com/office/drawing/2014/chart" uri="{C3380CC4-5D6E-409C-BE32-E72D297353CC}">
+              <c16:uniqueId val="{00000004-9D08-4425-99DE-4E5501F36EC7}"/>
+            </c:ext>
+          </c:extLst>
+        </c:ser>
+        <c:ser>
+          <c:idx val="3"/>
+          <c:order val="3"/>
+          <c:tx>
+            <c:strRef>
+              <c:f>Sheet1!$E$1</c:f>
+              <c:strCache>
+                <c:ptCount val="1"/>
+                <c:pt idx="0">
+                  <c:v>Series 4</c:v>
+                </c:pt>
+              </c:strCache>
+            </c:strRef>
+          </c:tx>
+          <c:spPr>
+            <a:solidFill>
+              <a:schemeClr val="accent4"/>
+            </a:solidFill>
+            <a:ln>
+              <a:noFill/>
+            </a:ln>
+            <a:effectLst/>
+          </c:spPr>
+          <c:invertIfNegative val="0"/>
+          <c:dLbls>
+            <c:dLbl>
+              <c:idx val="0"/>
+              <c:layout>
+                <c:manualLayout>
+                  <c:x val="0.18961357411845259"/>
+                  <c:y val="-0.11764705882352941"/>
+                </c:manualLayout>
+              </c:layout>
+              <c:spPr>
+                <a:solidFill>
+                  <a:srgbClr val="FFC000"/>
+                </a:solidFill>
+                <a:ln>
+                  <a:noFill/>
+                </a:ln>
+                <a:effectLst/>
+              </c:spPr>
+              <c:txPr>
+                <a:bodyPr rot="0" spcFirstLastPara="1" vertOverflow="ellipsis" vert="horz" wrap="square" lIns="38100" tIns="19050" rIns="38100" bIns="19050" anchor="ctr" anchorCtr="1">
+                  <a:noAutofit/>
+                </a:bodyPr>
+                <a:lstStyle/>
+                <a:p>
+                  <a:pPr>
+                    <a:defRPr sz="1800" b="0" i="0" u="none" strike="noStrike" kern="1200" baseline="0">
+                      <a:solidFill>
+                        <a:schemeClr val="bg1"/>
+                      </a:solidFill>
+                      <a:latin typeface="+mn-lt"/>
+                      <a:ea typeface="+mn-ea"/>
+                      <a:cs typeface="+mn-cs"/>
+                    </a:defRPr>
+                  </a:pPr>
+                  <a:endParaRPr lang="en-US"/>
+                </a:p>
+              </c:txPr>
+              <c:dLblPos val="ctr"/>
+              <c:showLegendKey val="0"/>
+              <c:showVal val="1"/>
+              <c:showCatName val="0"/>
+              <c:showSerName val="0"/>
+              <c:showPercent val="0"/>
+              <c:showBubbleSize val="0"/>
+              <c:extLst>
+                <c:ext xmlns:c15="http://schemas.microsoft.com/office/drawing/2012/chart" uri="{CE6537A1-D6FC-4f65-9D91-7224C49458BB}">
+                  <c15:layout>
+                    <c:manualLayout>
+                      <c:w val="6.4969854311689293E-2"/>
+                      <c:h val="7.8376992091674813E-2"/>
+                    </c:manualLayout>
+                  </c15:layout>
+                </c:ext>
+                <c:ext xmlns:c16="http://schemas.microsoft.com/office/drawing/2014/chart" uri="{C3380CC4-5D6E-409C-BE32-E72D297353CC}">
+                  <c16:uniqueId val="{00000000-C41C-4F54-805C-4E5E94C272C8}"/>
+                </c:ext>
+              </c:extLst>
+            </c:dLbl>
+            <c:spPr>
+              <a:solidFill>
+                <a:srgbClr val="FFC000"/>
+              </a:solidFill>
+              <a:ln>
+                <a:noFill/>
+              </a:ln>
+              <a:effectLst/>
+            </c:spPr>
+            <c:txPr>
+              <a:bodyPr rot="0" spcFirstLastPara="1" vertOverflow="ellipsis" vert="horz" wrap="square" lIns="38100" tIns="19050" rIns="38100" bIns="19050" anchor="ctr" anchorCtr="1">
+                <a:spAutoFit/>
+              </a:bodyPr>
+              <a:lstStyle/>
+              <a:p>
+                <a:pPr>
+                  <a:defRPr sz="8000" b="0" i="0" u="none" strike="noStrike" kern="1200" baseline="0">
+                    <a:solidFill>
+                      <a:schemeClr val="bg1"/>
+                    </a:solidFill>
+                    <a:latin typeface="+mn-lt"/>
+                    <a:ea typeface="+mn-ea"/>
+                    <a:cs typeface="+mn-cs"/>
+                  </a:defRPr>
+                </a:pPr>
+                <a:endParaRPr lang="en-US"/>
+              </a:p>
+            </c:txPr>
+            <c:dLblPos val="ctr"/>
+            <c:showLegendKey val="0"/>
+            <c:showVal val="1"/>
+            <c:showCatName val="0"/>
+            <c:showSerName val="0"/>
+            <c:showPercent val="0"/>
+            <c:showBubbleSize val="0"/>
+            <c:showLeaderLines val="0"/>
+            <c:extLst>
+              <c:ext xmlns:c15="http://schemas.microsoft.com/office/drawing/2012/chart" uri="{CE6537A1-D6FC-4f65-9D91-7224C49458BB}">
+                <c15:showLeaderLines val="1"/>
+                <c15:leaderLines>
+                  <c:spPr>
+                    <a:ln w="9525" cap="flat" cmpd="sng" algn="ctr">
+                      <a:solidFill>
+                        <a:schemeClr val="tx1">
+                          <a:lumMod val="35000"/>
+                          <a:lumOff val="65000"/>
+                        </a:schemeClr>
+                      </a:solidFill>
+                      <a:round/>
+                    </a:ln>
+                    <a:effectLst/>
+                  </c:spPr>
+                </c15:leaderLines>
+              </c:ext>
+            </c:extLst>
+          </c:dLbls>
+          <c:cat>
+            <c:strRef>
+              <c:f>Sheet1!$A$2</c:f>
+              <c:strCache>
+                <c:ptCount val="1"/>
+                <c:pt idx="0">
+                  <c:v>Category 1</c:v>
+                </c:pt>
+              </c:strCache>
+            </c:strRef>
+          </c:cat>
+          <c:val>
+            <c:numRef>
+              <c:f>Sheet1!$E$2</c:f>
+              <c:numCache>
+                <c:formatCode>General</c:formatCode>
+                <c:ptCount val="1"/>
+                <c:pt idx="0">
+                  <c:v>4.5</c:v>
+                </c:pt>
+              </c:numCache>
+            </c:numRef>
+          </c:val>
+          <c:extLst>
+            <c:ext xmlns:c16="http://schemas.microsoft.com/office/drawing/2014/chart" uri="{C3380CC4-5D6E-409C-BE32-E72D297353CC}">
+              <c16:uniqueId val="{00000005-9D08-4425-99DE-4E5501F36EC7}"/>
+            </c:ext>
+          </c:extLst>
+        </c:ser>
+        <c:dLbls>
+          <c:dLblPos val="ctr"/>
+          <c:showLegendKey val="0"/>
+          <c:showVal val="1"/>
+          <c:showCatName val="0"/>
+          <c:showSerName val="0"/>
+          <c:showPercent val="0"/>
+          <c:showBubbleSize val="0"/>
+        </c:dLbls>
+        <c:gapWidth val="150"/>
+        <c:overlap val="100"/>
+        <c:axId val="849142544"/>
+        <c:axId val="849167024"/>
+      </c:barChart>
+      <c:catAx>
+        <c:axId val="849142544"/>
+        <c:scaling>
+          <c:orientation val="minMax"/>
+        </c:scaling>
+        <c:delete val="1"/>
+        <c:axPos val="b"/>
+        <c:numFmt formatCode="General" sourceLinked="1"/>
+        <c:majorTickMark val="none"/>
+        <c:minorTickMark val="none"/>
+        <c:tickLblPos val="nextTo"/>
+        <c:crossAx val="849167024"/>
+        <c:crosses val="autoZero"/>
+        <c:auto val="1"/>
+        <c:lblAlgn val="ctr"/>
+        <c:lblOffset val="100"/>
+        <c:noMultiLvlLbl val="0"/>
+      </c:catAx>
+      <c:valAx>
+        <c:axId val="849167024"/>
+        <c:scaling>
+          <c:orientation val="minMax"/>
+        </c:scaling>
+        <c:delete val="1"/>
+        <c:axPos val="l"/>
+        <c:numFmt formatCode="General" sourceLinked="1"/>
+        <c:majorTickMark val="none"/>
+        <c:minorTickMark val="none"/>
+        <c:tickLblPos val="nextTo"/>
+        <c:crossAx val="849142544"/>
+        <c:crosses val="autoZero"/>
+        <c:crossBetween val="between"/>
+      </c:valAx>
+      <c:spPr>
+        <a:noFill/>
+        <a:ln>
+          <a:noFill/>
+        </a:ln>
+        <a:effectLst/>
+      </c:spPr>
+    </c:plotArea>
+    <c:plotVisOnly val="1"/>
+    <c:dispBlanksAs val="gap"/>
+    <c:showDLblsOverMax val="0"/>
+    <c:extLst>
+      <c:ext xmlns:c16r3="http://schemas.microsoft.com/office/drawing/2017/03/chart" uri="{56B9EC1D-385E-4148-901F-78D8002777C0}">
+        <c16r3:dataDisplayOptions16>
+          <c16r3:dispNaAsBlank val="1"/>
+        </c16r3:dataDisplayOptions16>
+      </c:ext>
+    </c:extLst>
+  </c:chart>
+  <c:spPr>
+    <a:noFill/>
+    <a:ln>
+      <a:noFill/>
+    </a:ln>
+    <a:effectLst/>
+  </c:spPr>
+  <c:txPr>
+    <a:bodyPr/>
+    <a:lstStyle/>
+    <a:p>
+      <a:pPr>
+        <a:defRPr/>
+      </a:pPr>
+      <a:endParaRPr lang="en-US"/>
+    </a:p>
+  </c:txPr>
+  <c:externalData r:id="rId3">
+    <c:autoUpdate val="0"/>
+  </c:externalData>
+</c:chartSpace>
+</file>
+
 <file path=ppt/charts/colors1.xml><?xml version="1.0" encoding="utf-8"?>
 <cs:colorStyle xmlns:cs="http://schemas.microsoft.com/office/drawing/2012/chartStyle" xmlns:a="http://schemas.openxmlformats.org/drawingml/2006/main" meth="cycle" id="10">
   <a:schemeClr val="accent1"/>
@@ -1084,6 +2111,46 @@
 </file>
 
 <file path=ppt/charts/colors2.xml><?xml version="1.0" encoding="utf-8"?>
+<cs:colorStyle xmlns:cs="http://schemas.microsoft.com/office/drawing/2012/chartStyle" xmlns:a="http://schemas.openxmlformats.org/drawingml/2006/main" meth="cycle" id="10">
+  <a:schemeClr val="accent1"/>
+  <a:schemeClr val="accent2"/>
+  <a:schemeClr val="accent3"/>
+  <a:schemeClr val="accent4"/>
+  <a:schemeClr val="accent5"/>
+  <a:schemeClr val="accent6"/>
+  <cs:variation/>
+  <cs:variation>
+    <a:lumMod val="60000"/>
+  </cs:variation>
+  <cs:variation>
+    <a:lumMod val="80000"/>
+    <a:lumOff val="20000"/>
+  </cs:variation>
+  <cs:variation>
+    <a:lumMod val="80000"/>
+  </cs:variation>
+  <cs:variation>
+    <a:lumMod val="60000"/>
+    <a:lumOff val="40000"/>
+  </cs:variation>
+  <cs:variation>
+    <a:lumMod val="50000"/>
+  </cs:variation>
+  <cs:variation>
+    <a:lumMod val="70000"/>
+    <a:lumOff val="30000"/>
+  </cs:variation>
+  <cs:variation>
+    <a:lumMod val="70000"/>
+  </cs:variation>
+  <cs:variation>
+    <a:lumMod val="50000"/>
+    <a:lumOff val="50000"/>
+  </cs:variation>
+</cs:colorStyle>
+</file>
+
+<file path=ppt/charts/colors3.xml><?xml version="1.0" encoding="utf-8"?>
 <cs:colorStyle xmlns:cs="http://schemas.microsoft.com/office/drawing/2012/chartStyle" xmlns:a="http://schemas.openxmlformats.org/drawingml/2006/main" meth="cycle" id="10">
   <a:schemeClr val="accent1"/>
   <a:schemeClr val="accent2"/>
@@ -2129,6 +3196,861 @@
 </cs:chartStyle>
 </file>
 
+<file path=ppt/charts/style3.xml><?xml version="1.0" encoding="utf-8"?>
+<cs:chartStyle xmlns:cs="http://schemas.microsoft.com/office/drawing/2012/chartStyle" xmlns:a="http://schemas.openxmlformats.org/drawingml/2006/main" id="297">
+  <cs:axisTitle>
+    <cs:lnRef idx="0"/>
+    <cs:fillRef idx="0"/>
+    <cs:effectRef idx="0"/>
+    <cs:fontRef idx="minor">
+      <a:schemeClr val="tx1">
+        <a:lumMod val="65000"/>
+        <a:lumOff val="35000"/>
+      </a:schemeClr>
+    </cs:fontRef>
+    <cs:defRPr sz="1330" kern="1200"/>
+  </cs:axisTitle>
+  <cs:categoryAxis>
+    <cs:lnRef idx="0"/>
+    <cs:fillRef idx="0"/>
+    <cs:effectRef idx="0"/>
+    <cs:fontRef idx="minor">
+      <a:schemeClr val="tx1">
+        <a:lumMod val="65000"/>
+        <a:lumOff val="35000"/>
+      </a:schemeClr>
+    </cs:fontRef>
+    <cs:spPr>
+      <a:ln w="9525" cap="flat" cmpd="sng" algn="ctr">
+        <a:solidFill>
+          <a:schemeClr val="tx1">
+            <a:lumMod val="15000"/>
+            <a:lumOff val="85000"/>
+          </a:schemeClr>
+        </a:solidFill>
+        <a:round/>
+      </a:ln>
+    </cs:spPr>
+    <cs:defRPr sz="1197" kern="1200"/>
+  </cs:categoryAxis>
+  <cs:chartArea mods="allowNoFillOverride allowNoLineOverride">
+    <cs:lnRef idx="0"/>
+    <cs:fillRef idx="0"/>
+    <cs:effectRef idx="0"/>
+    <cs:fontRef idx="minor">
+      <a:schemeClr val="tx1"/>
+    </cs:fontRef>
+    <cs:spPr>
+      <a:solidFill>
+        <a:schemeClr val="bg1"/>
+      </a:solidFill>
+      <a:ln w="9525" cap="flat" cmpd="sng" algn="ctr">
+        <a:solidFill>
+          <a:schemeClr val="tx1">
+            <a:lumMod val="15000"/>
+            <a:lumOff val="85000"/>
+          </a:schemeClr>
+        </a:solidFill>
+        <a:round/>
+      </a:ln>
+    </cs:spPr>
+    <cs:defRPr sz="1330" kern="1200"/>
+  </cs:chartArea>
+  <cs:dataLabel>
+    <cs:lnRef idx="0"/>
+    <cs:fillRef idx="0"/>
+    <cs:effectRef idx="0"/>
+    <cs:fontRef idx="minor">
+      <a:schemeClr val="tx1">
+        <a:lumMod val="75000"/>
+        <a:lumOff val="25000"/>
+      </a:schemeClr>
+    </cs:fontRef>
+    <cs:defRPr sz="1197" kern="1200"/>
+  </cs:dataLabel>
+  <cs:dataLabelCallout>
+    <cs:lnRef idx="0"/>
+    <cs:fillRef idx="0"/>
+    <cs:effectRef idx="0"/>
+    <cs:fontRef idx="minor">
+      <a:schemeClr val="dk1">
+        <a:lumMod val="65000"/>
+        <a:lumOff val="35000"/>
+      </a:schemeClr>
+    </cs:fontRef>
+    <cs:spPr>
+      <a:solidFill>
+        <a:schemeClr val="lt1"/>
+      </a:solidFill>
+      <a:ln>
+        <a:solidFill>
+          <a:schemeClr val="dk1">
+            <a:lumMod val="25000"/>
+            <a:lumOff val="75000"/>
+          </a:schemeClr>
+        </a:solidFill>
+      </a:ln>
+    </cs:spPr>
+    <cs:defRPr sz="1197" kern="1200"/>
+    <cs:bodyPr rot="0" spcFirstLastPara="1" vertOverflow="clip" horzOverflow="clip" vert="horz" wrap="square" lIns="36576" tIns="18288" rIns="36576" bIns="18288" anchor="ctr" anchorCtr="1">
+      <a:spAutoFit/>
+    </cs:bodyPr>
+  </cs:dataLabelCallout>
+  <cs:dataPoint>
+    <cs:lnRef idx="0"/>
+    <cs:fillRef idx="1">
+      <cs:styleClr val="auto"/>
+    </cs:fillRef>
+    <cs:effectRef idx="0"/>
+    <cs:fontRef idx="minor">
+      <a:schemeClr val="tx1"/>
+    </cs:fontRef>
+  </cs:dataPoint>
+  <cs:dataPoint3D>
+    <cs:lnRef idx="0"/>
+    <cs:fillRef idx="1">
+      <cs:styleClr val="auto"/>
+    </cs:fillRef>
+    <cs:effectRef idx="0"/>
+    <cs:fontRef idx="minor">
+      <a:schemeClr val="tx1"/>
+    </cs:fontRef>
+  </cs:dataPoint3D>
+  <cs:dataPointLine>
+    <cs:lnRef idx="0">
+      <cs:styleClr val="auto"/>
+    </cs:lnRef>
+    <cs:fillRef idx="1"/>
+    <cs:effectRef idx="0"/>
+    <cs:fontRef idx="minor">
+      <a:schemeClr val="tx1"/>
+    </cs:fontRef>
+    <cs:spPr>
+      <a:ln w="28575" cap="rnd">
+        <a:solidFill>
+          <a:schemeClr val="phClr"/>
+        </a:solidFill>
+        <a:round/>
+      </a:ln>
+    </cs:spPr>
+  </cs:dataPointLine>
+  <cs:dataPointMarker>
+    <cs:lnRef idx="0">
+      <cs:styleClr val="auto"/>
+    </cs:lnRef>
+    <cs:fillRef idx="1">
+      <cs:styleClr val="auto"/>
+    </cs:fillRef>
+    <cs:effectRef idx="0"/>
+    <cs:fontRef idx="minor">
+      <a:schemeClr val="tx1"/>
+    </cs:fontRef>
+    <cs:spPr>
+      <a:ln w="9525">
+        <a:solidFill>
+          <a:schemeClr val="phClr"/>
+        </a:solidFill>
+      </a:ln>
+    </cs:spPr>
+  </cs:dataPointMarker>
+  <cs:dataPointMarkerLayout symbol="circle" size="5"/>
+  <cs:dataPointWireframe>
+    <cs:lnRef idx="0">
+      <cs:styleClr val="auto"/>
+    </cs:lnRef>
+    <cs:fillRef idx="1"/>
+    <cs:effectRef idx="0"/>
+    <cs:fontRef idx="minor">
+      <a:schemeClr val="tx1"/>
+    </cs:fontRef>
+    <cs:spPr>
+      <a:ln w="9525" cap="rnd">
+        <a:solidFill>
+          <a:schemeClr val="phClr"/>
+        </a:solidFill>
+        <a:round/>
+      </a:ln>
+    </cs:spPr>
+  </cs:dataPointWireframe>
+  <cs:dataTable>
+    <cs:lnRef idx="0"/>
+    <cs:fillRef idx="0"/>
+    <cs:effectRef idx="0"/>
+    <cs:fontRef idx="minor">
+      <a:schemeClr val="tx1">
+        <a:lumMod val="65000"/>
+        <a:lumOff val="35000"/>
+      </a:schemeClr>
+    </cs:fontRef>
+    <cs:spPr>
+      <a:noFill/>
+      <a:ln w="9525" cap="flat" cmpd="sng" algn="ctr">
+        <a:solidFill>
+          <a:schemeClr val="tx1">
+            <a:lumMod val="15000"/>
+            <a:lumOff val="85000"/>
+          </a:schemeClr>
+        </a:solidFill>
+        <a:round/>
+      </a:ln>
+    </cs:spPr>
+    <cs:defRPr sz="1197" kern="1200"/>
+  </cs:dataTable>
+  <cs:downBar>
+    <cs:lnRef idx="0"/>
+    <cs:fillRef idx="0"/>
+    <cs:effectRef idx="0"/>
+    <cs:fontRef idx="minor">
+      <a:schemeClr val="tx1"/>
+    </cs:fontRef>
+    <cs:spPr>
+      <a:solidFill>
+        <a:schemeClr val="dk1">
+          <a:lumMod val="75000"/>
+          <a:lumOff val="25000"/>
+        </a:schemeClr>
+      </a:solidFill>
+      <a:ln w="9525" cap="flat" cmpd="sng" algn="ctr">
+        <a:solidFill>
+          <a:schemeClr val="tx1">
+            <a:lumMod val="65000"/>
+            <a:lumOff val="35000"/>
+          </a:schemeClr>
+        </a:solidFill>
+        <a:round/>
+      </a:ln>
+    </cs:spPr>
+  </cs:downBar>
+  <cs:dropLine>
+    <cs:lnRef idx="0"/>
+    <cs:fillRef idx="0"/>
+    <cs:effectRef idx="0"/>
+    <cs:fontRef idx="minor">
+      <a:schemeClr val="tx1"/>
+    </cs:fontRef>
+    <cs:spPr>
+      <a:ln w="9525" cap="flat" cmpd="sng" algn="ctr">
+        <a:solidFill>
+          <a:schemeClr val="tx1">
+            <a:lumMod val="35000"/>
+            <a:lumOff val="65000"/>
+          </a:schemeClr>
+        </a:solidFill>
+        <a:round/>
+      </a:ln>
+    </cs:spPr>
+  </cs:dropLine>
+  <cs:errorBar>
+    <cs:lnRef idx="0"/>
+    <cs:fillRef idx="0"/>
+    <cs:effectRef idx="0"/>
+    <cs:fontRef idx="minor">
+      <a:schemeClr val="tx1"/>
+    </cs:fontRef>
+    <cs:spPr>
+      <a:ln w="9525" cap="flat" cmpd="sng" algn="ctr">
+        <a:solidFill>
+          <a:schemeClr val="tx1">
+            <a:lumMod val="65000"/>
+            <a:lumOff val="35000"/>
+          </a:schemeClr>
+        </a:solidFill>
+        <a:round/>
+      </a:ln>
+    </cs:spPr>
+  </cs:errorBar>
+  <cs:floor>
+    <cs:lnRef idx="0"/>
+    <cs:fillRef idx="0"/>
+    <cs:effectRef idx="0"/>
+    <cs:fontRef idx="minor">
+      <a:schemeClr val="tx1"/>
+    </cs:fontRef>
+    <cs:spPr>
+      <a:noFill/>
+      <a:ln>
+        <a:noFill/>
+      </a:ln>
+    </cs:spPr>
+  </cs:floor>
+  <cs:gridlineMajor>
+    <cs:lnRef idx="0"/>
+    <cs:fillRef idx="0"/>
+    <cs:effectRef idx="0"/>
+    <cs:fontRef idx="minor">
+      <a:schemeClr val="tx1"/>
+    </cs:fontRef>
+    <cs:spPr>
+      <a:ln w="9525" cap="flat" cmpd="sng" algn="ctr">
+        <a:solidFill>
+          <a:schemeClr val="tx1">
+            <a:lumMod val="15000"/>
+            <a:lumOff val="85000"/>
+          </a:schemeClr>
+        </a:solidFill>
+        <a:round/>
+      </a:ln>
+    </cs:spPr>
+  </cs:gridlineMajor>
+  <cs:gridlineMinor>
+    <cs:lnRef idx="0"/>
+    <cs:fillRef idx="0"/>
+    <cs:effectRef idx="0"/>
+    <cs:fontRef idx="minor">
+      <a:schemeClr val="tx1"/>
+    </cs:fontRef>
+    <cs:spPr>
+      <a:ln w="9525" cap="flat" cmpd="sng" algn="ctr">
+        <a:solidFill>
+          <a:schemeClr val="tx1">
+            <a:lumMod val="5000"/>
+            <a:lumOff val="95000"/>
+          </a:schemeClr>
+        </a:solidFill>
+        <a:round/>
+      </a:ln>
+    </cs:spPr>
+  </cs:gridlineMinor>
+  <cs:hiLoLine>
+    <cs:lnRef idx="0"/>
+    <cs:fillRef idx="0"/>
+    <cs:effectRef idx="0"/>
+    <cs:fontRef idx="minor">
+      <a:schemeClr val="tx1"/>
+    </cs:fontRef>
+    <cs:spPr>
+      <a:ln w="9525" cap="flat" cmpd="sng" algn="ctr">
+        <a:solidFill>
+          <a:schemeClr val="tx1">
+            <a:lumMod val="50000"/>
+            <a:lumOff val="50000"/>
+          </a:schemeClr>
+        </a:solidFill>
+        <a:round/>
+      </a:ln>
+    </cs:spPr>
+  </cs:hiLoLine>
+  <cs:leaderLine>
+    <cs:lnRef idx="0"/>
+    <cs:fillRef idx="0"/>
+    <cs:effectRef idx="0"/>
+    <cs:fontRef idx="minor">
+      <a:schemeClr val="tx1"/>
+    </cs:fontRef>
+    <cs:spPr>
+      <a:ln w="9525" cap="flat" cmpd="sng" algn="ctr">
+        <a:solidFill>
+          <a:schemeClr val="tx1">
+            <a:lumMod val="35000"/>
+            <a:lumOff val="65000"/>
+          </a:schemeClr>
+        </a:solidFill>
+        <a:round/>
+      </a:ln>
+    </cs:spPr>
+  </cs:leaderLine>
+  <cs:legend>
+    <cs:lnRef idx="0"/>
+    <cs:fillRef idx="0"/>
+    <cs:effectRef idx="0"/>
+    <cs:fontRef idx="minor">
+      <a:schemeClr val="tx1">
+        <a:lumMod val="65000"/>
+        <a:lumOff val="35000"/>
+      </a:schemeClr>
+    </cs:fontRef>
+    <cs:defRPr sz="1197" kern="1200"/>
+  </cs:legend>
+  <cs:plotArea mods="allowNoFillOverride allowNoLineOverride">
+    <cs:lnRef idx="0"/>
+    <cs:fillRef idx="0"/>
+    <cs:effectRef idx="0"/>
+    <cs:fontRef idx="minor">
+      <a:schemeClr val="tx1"/>
+    </cs:fontRef>
+  </cs:plotArea>
+  <cs:plotArea3D mods="allowNoFillOverride allowNoLineOverride">
+    <cs:lnRef idx="0"/>
+    <cs:fillRef idx="0"/>
+    <cs:effectRef idx="0"/>
+    <cs:fontRef idx="minor">
+      <a:schemeClr val="tx1"/>
+    </cs:fontRef>
+  </cs:plotArea3D>
+  <cs:seriesAxis>
+    <cs:lnRef idx="0"/>
+    <cs:fillRef idx="0"/>
+    <cs:effectRef idx="0"/>
+    <cs:fontRef idx="minor">
+      <a:schemeClr val="tx1">
+        <a:lumMod val="65000"/>
+        <a:lumOff val="35000"/>
+      </a:schemeClr>
+    </cs:fontRef>
+    <cs:defRPr sz="1197" kern="1200"/>
+  </cs:seriesAxis>
+  <cs:seriesLine>
+    <cs:lnRef idx="0"/>
+    <cs:fillRef idx="0"/>
+    <cs:effectRef idx="0"/>
+    <cs:fontRef idx="minor">
+      <a:schemeClr val="tx1"/>
+    </cs:fontRef>
+    <cs:spPr>
+      <a:ln w="9525" cap="flat" cmpd="sng" algn="ctr">
+        <a:solidFill>
+          <a:schemeClr val="tx1">
+            <a:lumMod val="35000"/>
+            <a:lumOff val="65000"/>
+          </a:schemeClr>
+        </a:solidFill>
+        <a:round/>
+      </a:ln>
+    </cs:spPr>
+  </cs:seriesLine>
+  <cs:title>
+    <cs:lnRef idx="0"/>
+    <cs:fillRef idx="0"/>
+    <cs:effectRef idx="0"/>
+    <cs:fontRef idx="minor">
+      <a:schemeClr val="tx1">
+        <a:lumMod val="65000"/>
+        <a:lumOff val="35000"/>
+      </a:schemeClr>
+    </cs:fontRef>
+    <cs:defRPr sz="1862" b="0" kern="1200" spc="0" baseline="0"/>
+  </cs:title>
+  <cs:trendline>
+    <cs:lnRef idx="0">
+      <cs:styleClr val="auto"/>
+    </cs:lnRef>
+    <cs:fillRef idx="0"/>
+    <cs:effectRef idx="0"/>
+    <cs:fontRef idx="minor">
+      <a:schemeClr val="tx1"/>
+    </cs:fontRef>
+    <cs:spPr>
+      <a:ln w="19050" cap="rnd">
+        <a:solidFill>
+          <a:schemeClr val="phClr"/>
+        </a:solidFill>
+        <a:prstDash val="sysDot"/>
+      </a:ln>
+    </cs:spPr>
+  </cs:trendline>
+  <cs:trendlineLabel>
+    <cs:lnRef idx="0"/>
+    <cs:fillRef idx="0"/>
+    <cs:effectRef idx="0"/>
+    <cs:fontRef idx="minor">
+      <a:schemeClr val="tx1">
+        <a:lumMod val="65000"/>
+        <a:lumOff val="35000"/>
+      </a:schemeClr>
+    </cs:fontRef>
+    <cs:defRPr sz="1197" kern="1200"/>
+  </cs:trendlineLabel>
+  <cs:upBar>
+    <cs:lnRef idx="0"/>
+    <cs:fillRef idx="0"/>
+    <cs:effectRef idx="0"/>
+    <cs:fontRef idx="minor">
+      <a:schemeClr val="tx1"/>
+    </cs:fontRef>
+    <cs:spPr>
+      <a:solidFill>
+        <a:schemeClr val="lt1"/>
+      </a:solidFill>
+      <a:ln w="9525" cap="flat" cmpd="sng" algn="ctr">
+        <a:solidFill>
+          <a:schemeClr val="tx1">
+            <a:lumMod val="65000"/>
+            <a:lumOff val="35000"/>
+          </a:schemeClr>
+        </a:solidFill>
+        <a:round/>
+      </a:ln>
+    </cs:spPr>
+  </cs:upBar>
+  <cs:valueAxis>
+    <cs:lnRef idx="0"/>
+    <cs:fillRef idx="0"/>
+    <cs:effectRef idx="0"/>
+    <cs:fontRef idx="minor">
+      <a:schemeClr val="tx1">
+        <a:lumMod val="65000"/>
+        <a:lumOff val="35000"/>
+      </a:schemeClr>
+    </cs:fontRef>
+    <cs:defRPr sz="1197" kern="1200"/>
+  </cs:valueAxis>
+  <cs:wall>
+    <cs:lnRef idx="0"/>
+    <cs:fillRef idx="0"/>
+    <cs:effectRef idx="0"/>
+    <cs:fontRef idx="minor">
+      <a:schemeClr val="tx1"/>
+    </cs:fontRef>
+    <cs:spPr>
+      <a:noFill/>
+      <a:ln>
+        <a:noFill/>
+      </a:ln>
+    </cs:spPr>
+  </cs:wall>
+</cs:chartStyle>
+</file>
+
+<file path=ppt/notesMasters/notesMaster1.xml><?xml version="1.0" encoding="utf-8"?>
+<p:notesMaster xmlns:a="http://schemas.openxmlformats.org/drawingml/2006/main" xmlns:r="http://schemas.openxmlformats.org/officeDocument/2006/relationships" xmlns:p="http://schemas.openxmlformats.org/presentationml/2006/main">
+  <p:cSld>
+    <p:bg>
+      <p:bgRef idx="1001">
+        <a:schemeClr val="bg1"/>
+      </p:bgRef>
+    </p:bg>
+    <p:spTree>
+      <p:nvGrpSpPr>
+        <p:cNvPr id="1" name=""/>
+        <p:cNvGrpSpPr/>
+        <p:nvPr/>
+      </p:nvGrpSpPr>
+      <p:grpSpPr>
+        <a:xfrm>
+          <a:off x="0" y="0"/>
+          <a:ext cx="0" cy="0"/>
+          <a:chOff x="0" y="0"/>
+          <a:chExt cx="0" cy="0"/>
+        </a:xfrm>
+      </p:grpSpPr>
+      <p:sp>
+        <p:nvSpPr>
+          <p:cNvPr id="2" name="Header Placeholder 1"/>
+          <p:cNvSpPr>
+            <a:spLocks noGrp="1"/>
+          </p:cNvSpPr>
+          <p:nvPr>
+            <p:ph type="hdr" sz="quarter"/>
+          </p:nvPr>
+        </p:nvSpPr>
+        <p:spPr>
+          <a:xfrm>
+            <a:off x="0" y="0"/>
+            <a:ext cx="2971800" cy="458788"/>
+          </a:xfrm>
+          <a:prstGeom prst="rect">
+            <a:avLst/>
+          </a:prstGeom>
+        </p:spPr>
+        <p:txBody>
+          <a:bodyPr vert="horz" lIns="91440" tIns="45720" rIns="91440" bIns="45720" rtlCol="0"/>
+          <a:lstStyle>
+            <a:lvl1pPr algn="l">
+              <a:defRPr sz="1200"/>
+            </a:lvl1pPr>
+          </a:lstStyle>
+          <a:p>
+            <a:endParaRPr lang="en-IN"/>
+          </a:p>
+        </p:txBody>
+      </p:sp>
+      <p:sp>
+        <p:nvSpPr>
+          <p:cNvPr id="3" name="Date Placeholder 2"/>
+          <p:cNvSpPr>
+            <a:spLocks noGrp="1"/>
+          </p:cNvSpPr>
+          <p:nvPr>
+            <p:ph type="dt" idx="1"/>
+          </p:nvPr>
+        </p:nvSpPr>
+        <p:spPr>
+          <a:xfrm>
+            <a:off x="3884613" y="0"/>
+            <a:ext cx="2971800" cy="458788"/>
+          </a:xfrm>
+          <a:prstGeom prst="rect">
+            <a:avLst/>
+          </a:prstGeom>
+        </p:spPr>
+        <p:txBody>
+          <a:bodyPr vert="horz" lIns="91440" tIns="45720" rIns="91440" bIns="45720" rtlCol="0"/>
+          <a:lstStyle>
+            <a:lvl1pPr algn="r">
+              <a:defRPr sz="1200"/>
+            </a:lvl1pPr>
+          </a:lstStyle>
+          <a:p>
+            <a:fld id="{8B1AF6D7-0F32-4F05-B21A-8AF0CB26F94C}" type="datetimeFigureOut">
+              <a:rPr lang="en-IN" smtClean="0"/>
+              <a:t>26-06-2026</a:t>
+            </a:fld>
+            <a:endParaRPr lang="en-IN"/>
+          </a:p>
+        </p:txBody>
+      </p:sp>
+      <p:sp>
+        <p:nvSpPr>
+          <p:cNvPr id="4" name="Slide Image Placeholder 3"/>
+          <p:cNvSpPr>
+            <a:spLocks noGrp="1" noRot="1" noChangeAspect="1"/>
+          </p:cNvSpPr>
+          <p:nvPr>
+            <p:ph type="sldImg" idx="2"/>
+          </p:nvPr>
+        </p:nvSpPr>
+        <p:spPr>
+          <a:xfrm>
+            <a:off x="685800" y="1143000"/>
+            <a:ext cx="5486400" cy="3086100"/>
+          </a:xfrm>
+          <a:prstGeom prst="rect">
+            <a:avLst/>
+          </a:prstGeom>
+          <a:noFill/>
+          <a:ln w="12700">
+            <a:solidFill>
+              <a:prstClr val="black"/>
+            </a:solidFill>
+          </a:ln>
+        </p:spPr>
+        <p:txBody>
+          <a:bodyPr vert="horz" lIns="91440" tIns="45720" rIns="91440" bIns="45720" rtlCol="0" anchor="ctr"/>
+          <a:lstStyle/>
+          <a:p>
+            <a:endParaRPr lang="en-IN"/>
+          </a:p>
+        </p:txBody>
+      </p:sp>
+      <p:sp>
+        <p:nvSpPr>
+          <p:cNvPr id="5" name="Notes Placeholder 4"/>
+          <p:cNvSpPr>
+            <a:spLocks noGrp="1"/>
+          </p:cNvSpPr>
+          <p:nvPr>
+            <p:ph type="body" sz="quarter" idx="3"/>
+          </p:nvPr>
+        </p:nvSpPr>
+        <p:spPr>
+          <a:xfrm>
+            <a:off x="685800" y="4400550"/>
+            <a:ext cx="5486400" cy="3600450"/>
+          </a:xfrm>
+          <a:prstGeom prst="rect">
+            <a:avLst/>
+          </a:prstGeom>
+        </p:spPr>
+        <p:txBody>
+          <a:bodyPr vert="horz" lIns="91440" tIns="45720" rIns="91440" bIns="45720" rtlCol="0"/>
+          <a:lstStyle/>
+          <a:p>
+            <a:pPr lvl="0"/>
+            <a:r>
+              <a:rPr lang="en-US"/>
+              <a:t>Click to edit Master text styles</a:t>
+            </a:r>
+          </a:p>
+          <a:p>
+            <a:pPr lvl="1"/>
+            <a:r>
+              <a:rPr lang="en-US"/>
+              <a:t>Second level</a:t>
+            </a:r>
+          </a:p>
+          <a:p>
+            <a:pPr lvl="2"/>
+            <a:r>
+              <a:rPr lang="en-US"/>
+              <a:t>Third level</a:t>
+            </a:r>
+          </a:p>
+          <a:p>
+            <a:pPr lvl="3"/>
+            <a:r>
+              <a:rPr lang="en-US"/>
+              <a:t>Fourth level</a:t>
+            </a:r>
+          </a:p>
+          <a:p>
+            <a:pPr lvl="4"/>
+            <a:r>
+              <a:rPr lang="en-US"/>
+              <a:t>Fifth level</a:t>
+            </a:r>
+            <a:endParaRPr lang="en-IN"/>
+          </a:p>
+        </p:txBody>
+      </p:sp>
+      <p:sp>
+        <p:nvSpPr>
+          <p:cNvPr id="6" name="Footer Placeholder 5"/>
+          <p:cNvSpPr>
+            <a:spLocks noGrp="1"/>
+          </p:cNvSpPr>
+          <p:nvPr>
+            <p:ph type="ftr" sz="quarter" idx="4"/>
+          </p:nvPr>
+        </p:nvSpPr>
+        <p:spPr>
+          <a:xfrm>
+            <a:off x="0" y="8685213"/>
+            <a:ext cx="2971800" cy="458787"/>
+          </a:xfrm>
+          <a:prstGeom prst="rect">
+            <a:avLst/>
+          </a:prstGeom>
+        </p:spPr>
+        <p:txBody>
+          <a:bodyPr vert="horz" lIns="91440" tIns="45720" rIns="91440" bIns="45720" rtlCol="0" anchor="b"/>
+          <a:lstStyle>
+            <a:lvl1pPr algn="l">
+              <a:defRPr sz="1200"/>
+            </a:lvl1pPr>
+          </a:lstStyle>
+          <a:p>
+            <a:endParaRPr lang="en-IN"/>
+          </a:p>
+        </p:txBody>
+      </p:sp>
+      <p:sp>
+        <p:nvSpPr>
+          <p:cNvPr id="7" name="Slide Number Placeholder 6"/>
+          <p:cNvSpPr>
+            <a:spLocks noGrp="1"/>
+          </p:cNvSpPr>
+          <p:nvPr>
+            <p:ph type="sldNum" sz="quarter" idx="5"/>
+          </p:nvPr>
+        </p:nvSpPr>
+        <p:spPr>
+          <a:xfrm>
+            <a:off x="3884613" y="8685213"/>
+            <a:ext cx="2971800" cy="458787"/>
+          </a:xfrm>
+          <a:prstGeom prst="rect">
+            <a:avLst/>
+          </a:prstGeom>
+        </p:spPr>
+        <p:txBody>
+          <a:bodyPr vert="horz" lIns="91440" tIns="45720" rIns="91440" bIns="45720" rtlCol="0" anchor="b"/>
+          <a:lstStyle>
+            <a:lvl1pPr algn="r">
+              <a:defRPr sz="1200"/>
+            </a:lvl1pPr>
+          </a:lstStyle>
+          <a:p>
+            <a:fld id="{F849BE13-E5DD-4ADC-A243-D0627F8BD02D}" type="slidenum">
+              <a:rPr lang="en-IN" smtClean="0"/>
+              <a:t>‹#›</a:t>
+            </a:fld>
+            <a:endParaRPr lang="en-IN"/>
+          </a:p>
+        </p:txBody>
+      </p:sp>
+    </p:spTree>
+    <p:extLst>
+      <p:ext uri="{BB962C8B-B14F-4D97-AF65-F5344CB8AC3E}">
+        <p14:creationId xmlns:p14="http://schemas.microsoft.com/office/powerpoint/2010/main" val="125510801"/>
+      </p:ext>
+    </p:extLst>
+  </p:cSld>
+  <p:clrMap bg1="lt1" tx1="dk1" bg2="lt2" tx2="dk2" accent1="accent1" accent2="accent2" accent3="accent3" accent4="accent4" accent5="accent5" accent6="accent6" hlink="hlink" folHlink="folHlink"/>
+  <p:notesStyle>
+    <a:lvl1pPr marL="0" algn="l" defTabSz="914400" rtl="0" eaLnBrk="1" latinLnBrk="0" hangingPunct="1">
+      <a:defRPr sz="1200" kern="1200">
+        <a:solidFill>
+          <a:schemeClr val="tx1"/>
+        </a:solidFill>
+        <a:latin typeface="+mn-lt"/>
+        <a:ea typeface="+mn-ea"/>
+        <a:cs typeface="+mn-cs"/>
+      </a:defRPr>
+    </a:lvl1pPr>
+    <a:lvl2pPr marL="457200" algn="l" defTabSz="914400" rtl="0" eaLnBrk="1" latinLnBrk="0" hangingPunct="1">
+      <a:defRPr sz="1200" kern="1200">
+        <a:solidFill>
+          <a:schemeClr val="tx1"/>
+        </a:solidFill>
+        <a:latin typeface="+mn-lt"/>
+        <a:ea typeface="+mn-ea"/>
+        <a:cs typeface="+mn-cs"/>
+      </a:defRPr>
+    </a:lvl2pPr>
+    <a:lvl3pPr marL="914400" algn="l" defTabSz="914400" rtl="0" eaLnBrk="1" latinLnBrk="0" hangingPunct="1">
+      <a:defRPr sz="1200" kern="1200">
+        <a:solidFill>
+          <a:schemeClr val="tx1"/>
+        </a:solidFill>
+        <a:latin typeface="+mn-lt"/>
+        <a:ea typeface="+mn-ea"/>
+        <a:cs typeface="+mn-cs"/>
+      </a:defRPr>
+    </a:lvl3pPr>
+    <a:lvl4pPr marL="1371600" algn="l" defTabSz="914400" rtl="0" eaLnBrk="1" latinLnBrk="0" hangingPunct="1">
+      <a:defRPr sz="1200" kern="1200">
+        <a:solidFill>
+          <a:schemeClr val="tx1"/>
+        </a:solidFill>
+        <a:latin typeface="+mn-lt"/>
+        <a:ea typeface="+mn-ea"/>
+        <a:cs typeface="+mn-cs"/>
+      </a:defRPr>
+    </a:lvl4pPr>
+    <a:lvl5pPr marL="1828800" algn="l" defTabSz="914400" rtl="0" eaLnBrk="1" latinLnBrk="0" hangingPunct="1">
+      <a:defRPr sz="1200" kern="1200">
+        <a:solidFill>
+          <a:schemeClr val="tx1"/>
+        </a:solidFill>
+        <a:latin typeface="+mn-lt"/>
+        <a:ea typeface="+mn-ea"/>
+        <a:cs typeface="+mn-cs"/>
+      </a:defRPr>
+    </a:lvl5pPr>
+    <a:lvl6pPr marL="2286000" algn="l" defTabSz="914400" rtl="0" eaLnBrk="1" latinLnBrk="0" hangingPunct="1">
+      <a:defRPr sz="1200" kern="1200">
+        <a:solidFill>
+          <a:schemeClr val="tx1"/>
+        </a:solidFill>
+        <a:latin typeface="+mn-lt"/>
+        <a:ea typeface="+mn-ea"/>
+        <a:cs typeface="+mn-cs"/>
+      </a:defRPr>
+    </a:lvl6pPr>
+    <a:lvl7pPr marL="2743200" algn="l" defTabSz="914400" rtl="0" eaLnBrk="1" latinLnBrk="0" hangingPunct="1">
+      <a:defRPr sz="1200" kern="1200">
+        <a:solidFill>
+          <a:schemeClr val="tx1"/>
+        </a:solidFill>
+        <a:latin typeface="+mn-lt"/>
+        <a:ea typeface="+mn-ea"/>
+        <a:cs typeface="+mn-cs"/>
+      </a:defRPr>
+    </a:lvl7pPr>
+    <a:lvl8pPr marL="3200400" algn="l" defTabSz="914400" rtl="0" eaLnBrk="1" latinLnBrk="0" hangingPunct="1">
+      <a:defRPr sz="1200" kern="1200">
+        <a:solidFill>
+          <a:schemeClr val="tx1"/>
+        </a:solidFill>
+        <a:latin typeface="+mn-lt"/>
+        <a:ea typeface="+mn-ea"/>
+        <a:cs typeface="+mn-cs"/>
+      </a:defRPr>
+    </a:lvl8pPr>
+    <a:lvl9pPr marL="3657600" algn="l" defTabSz="914400" rtl="0" eaLnBrk="1" latinLnBrk="0" hangingPunct="1">
+      <a:defRPr sz="1200" kern="1200">
+        <a:solidFill>
+          <a:schemeClr val="tx1"/>
+        </a:solidFill>
+        <a:latin typeface="+mn-lt"/>
+        <a:ea typeface="+mn-ea"/>
+        <a:cs typeface="+mn-cs"/>
+      </a:defRPr>
+    </a:lvl9pPr>
+  </p:notesStyle>
+</p:notesMaster>
+</file>
+
 <file path=ppt/slideLayouts/slideLayout1.xml><?xml version="1.0" encoding="utf-8"?>
 <p:sldLayout xmlns:a="http://schemas.openxmlformats.org/drawingml/2006/main" xmlns:r="http://schemas.openxmlformats.org/officeDocument/2006/relationships" xmlns:p="http://schemas.openxmlformats.org/presentationml/2006/main" type="title" preserve="1">
   <p:cSld name="Title Slide">
@@ -2278,7 +4200,7 @@
           <a:p>
             <a:fld id="{0490EA95-AFA9-47FA-B067-612933D1D62E}" type="datetimeFigureOut">
               <a:rPr lang="en-IN" smtClean="0"/>
-              <a:t>17-05-2026</a:t>
+              <a:t>26-06-2026</a:t>
             </a:fld>
             <a:endParaRPr lang="en-IN"/>
           </a:p>
@@ -2478,7 +4400,7 @@
           <a:p>
             <a:fld id="{0490EA95-AFA9-47FA-B067-612933D1D62E}" type="datetimeFigureOut">
               <a:rPr lang="en-IN" smtClean="0"/>
-              <a:t>17-05-2026</a:t>
+              <a:t>26-06-2026</a:t>
             </a:fld>
             <a:endParaRPr lang="en-IN"/>
           </a:p>
@@ -2688,7 +4610,7 @@
           <a:p>
             <a:fld id="{0490EA95-AFA9-47FA-B067-612933D1D62E}" type="datetimeFigureOut">
               <a:rPr lang="en-IN" smtClean="0"/>
-              <a:t>17-05-2026</a:t>
+              <a:t>26-06-2026</a:t>
             </a:fld>
             <a:endParaRPr lang="en-IN"/>
           </a:p>
@@ -2888,7 +4810,7 @@
           <a:p>
             <a:fld id="{0490EA95-AFA9-47FA-B067-612933D1D62E}" type="datetimeFigureOut">
               <a:rPr lang="en-IN" smtClean="0"/>
-              <a:t>17-05-2026</a:t>
+              <a:t>26-06-2026</a:t>
             </a:fld>
             <a:endParaRPr lang="en-IN"/>
           </a:p>
@@ -3164,7 +5086,7 @@
           <a:p>
             <a:fld id="{0490EA95-AFA9-47FA-B067-612933D1D62E}" type="datetimeFigureOut">
               <a:rPr lang="en-IN" smtClean="0"/>
-              <a:t>17-05-2026</a:t>
+              <a:t>26-06-2026</a:t>
             </a:fld>
             <a:endParaRPr lang="en-IN"/>
           </a:p>
@@ -3432,7 +5354,7 @@
           <a:p>
             <a:fld id="{0490EA95-AFA9-47FA-B067-612933D1D62E}" type="datetimeFigureOut">
               <a:rPr lang="en-IN" smtClean="0"/>
-              <a:t>17-05-2026</a:t>
+              <a:t>26-06-2026</a:t>
             </a:fld>
             <a:endParaRPr lang="en-IN"/>
           </a:p>
@@ -3847,7 +5769,7 @@
           <a:p>
             <a:fld id="{0490EA95-AFA9-47FA-B067-612933D1D62E}" type="datetimeFigureOut">
               <a:rPr lang="en-IN" smtClean="0"/>
-              <a:t>17-05-2026</a:t>
+              <a:t>26-06-2026</a:t>
             </a:fld>
             <a:endParaRPr lang="en-IN"/>
           </a:p>
@@ -3989,7 +5911,7 @@
           <a:p>
             <a:fld id="{0490EA95-AFA9-47FA-B067-612933D1D62E}" type="datetimeFigureOut">
               <a:rPr lang="en-IN" smtClean="0"/>
-              <a:t>17-05-2026</a:t>
+              <a:t>26-06-2026</a:t>
             </a:fld>
             <a:endParaRPr lang="en-IN"/>
           </a:p>
@@ -4102,7 +6024,7 @@
           <a:p>
             <a:fld id="{0490EA95-AFA9-47FA-B067-612933D1D62E}" type="datetimeFigureOut">
               <a:rPr lang="en-IN" smtClean="0"/>
-              <a:t>17-05-2026</a:t>
+              <a:t>26-06-2026</a:t>
             </a:fld>
             <a:endParaRPr lang="en-IN"/>
           </a:p>
@@ -4415,7 +6337,7 @@
           <a:p>
             <a:fld id="{0490EA95-AFA9-47FA-B067-612933D1D62E}" type="datetimeFigureOut">
               <a:rPr lang="en-IN" smtClean="0"/>
-              <a:t>17-05-2026</a:t>
+              <a:t>26-06-2026</a:t>
             </a:fld>
             <a:endParaRPr lang="en-IN"/>
           </a:p>
@@ -4704,7 +6626,7 @@
           <a:p>
             <a:fld id="{0490EA95-AFA9-47FA-B067-612933D1D62E}" type="datetimeFigureOut">
               <a:rPr lang="en-IN" smtClean="0"/>
-              <a:t>17-05-2026</a:t>
+              <a:t>26-06-2026</a:t>
             </a:fld>
             <a:endParaRPr lang="en-IN"/>
           </a:p>
@@ -4947,7 +6869,7 @@
           <a:p>
             <a:fld id="{0490EA95-AFA9-47FA-B067-612933D1D62E}" type="datetimeFigureOut">
               <a:rPr lang="en-IN" smtClean="0"/>
-              <a:t>17-05-2026</a:t>
+              <a:t>26-06-2026</a:t>
             </a:fld>
             <a:endParaRPr lang="en-IN"/>
           </a:p>
@@ -5366,6 +7288,52 @@
       </p:grpSpPr>
       <p:sp>
         <p:nvSpPr>
+          <p:cNvPr id="3" name="Shape">
+            <a:extLst>
+              <a:ext uri="{FF2B5EF4-FFF2-40B4-BE49-F238E27FC236}">
+                <a16:creationId xmlns:a16="http://schemas.microsoft.com/office/drawing/2014/main" id="{083EB01B-1DB3-3769-731D-AB321C5367ED}"/>
+              </a:ext>
+            </a:extLst>
+          </p:cNvPr>
+          <p:cNvSpPr/>
+          <p:nvPr/>
+        </p:nvSpPr>
+        <p:spPr>
+          <a:xfrm>
+            <a:off x="694592" y="545123"/>
+            <a:ext cx="10659208" cy="5750169"/>
+          </a:xfrm>
+          <a:prstGeom prst="roundRect">
+            <a:avLst/>
+          </a:prstGeom>
+        </p:spPr>
+        <p:style>
+          <a:lnRef idx="2">
+            <a:schemeClr val="accent3">
+              <a:shade val="15000"/>
+            </a:schemeClr>
+          </a:lnRef>
+          <a:fillRef idx="1">
+            <a:schemeClr val="accent3"/>
+          </a:fillRef>
+          <a:effectRef idx="0">
+            <a:schemeClr val="accent3"/>
+          </a:effectRef>
+          <a:fontRef idx="minor">
+            <a:schemeClr val="lt1"/>
+          </a:fontRef>
+        </p:style>
+        <p:txBody>
+          <a:bodyPr rtlCol="0" anchor="ctr"/>
+          <a:lstStyle/>
+          <a:p>
+            <a:pPr algn="ctr"/>
+            <a:endParaRPr lang="en-IN"/>
+          </a:p>
+        </p:txBody>
+      </p:sp>
+      <p:sp>
+        <p:nvSpPr>
           <p:cNvPr id="2" name="Title">
             <a:extLst>
               <a:ext uri="{FF2B5EF4-FFF2-40B4-BE49-F238E27FC236}">
@@ -5386,10 +7354,10 @@
           <a:lstStyle/>
           <a:p>
             <a:r>
-              <a:rPr lang="en-US" dirty="0"/>
+              <a:rPr lang="en-US"/>
               <a:t>Hello {{title}}</a:t>
             </a:r>
-            <a:endParaRPr lang="en-IN" dirty="0"/>
+            <a:endParaRPr lang="en-IN"/>
           </a:p>
         </p:txBody>
       </p:sp>
@@ -5409,7 +7377,7 @@
             <p:ph idx="1"/>
             <p:extLst>
               <p:ext uri="{D42A27DB-BD31-4B8C-83A1-F6EECF244321}">
-                <p14:modId xmlns:p14="http://schemas.microsoft.com/office/powerpoint/2010/main" val="1557177176"/>
+                <p14:modId xmlns:p14="http://schemas.microsoft.com/office/powerpoint/2010/main" val="1651760440"/>
               </p:ext>
             </p:extLst>
           </p:nvPr>
@@ -5482,10 +7450,10 @@
           <a:lstStyle/>
           <a:p>
             <a:r>
-              <a:rPr lang="en-US" dirty="0"/>
+              <a:rPr lang="en-US"/>
               <a:t>Hello {{title2}}</a:t>
             </a:r>
-            <a:endParaRPr lang="en-IN" dirty="0"/>
+            <a:endParaRPr lang="en-IN"/>
           </a:p>
         </p:txBody>
       </p:sp>
@@ -5572,16 +7540,23 @@
             <p:ph type="title"/>
           </p:nvPr>
         </p:nvSpPr>
-        <p:spPr/>
+        <p:spPr>
+          <a:xfrm>
+            <a:off x="838200" y="365125"/>
+            <a:ext cx="10515600" cy="369333"/>
+          </a:xfrm>
+        </p:spPr>
         <p:txBody>
-          <a:bodyPr/>
+          <a:bodyPr>
+            <a:normAutofit fontScale="90000"/>
+          </a:bodyPr>
           <a:lstStyle/>
           <a:p>
             <a:r>
-              <a:rPr lang="en-US" dirty="0"/>
+              <a:rPr lang="en-US" sz="2800"/>
               <a:t>Hello {{title}}</a:t>
             </a:r>
-            <a:endParaRPr lang="en-IN" dirty="0"/>
+            <a:endParaRPr lang="en-IN" sz="2800"/>
           </a:p>
         </p:txBody>
       </p:sp>
@@ -5601,14 +7576,312 @@
             <p:ph idx="1"/>
             <p:extLst>
               <p:ext uri="{D42A27DB-BD31-4B8C-83A1-F6EECF244321}">
-                <p14:modId xmlns:p14="http://schemas.microsoft.com/office/powerpoint/2010/main" val="143244436"/>
+                <p14:modId xmlns:p14="http://schemas.microsoft.com/office/powerpoint/2010/main" val="3682244565"/>
               </p:ext>
             </p:extLst>
           </p:nvPr>
         </p:nvGraphicFramePr>
         <p:xfrm>
-          <a:off x="838200" y="1825625"/>
-          <a:ext cx="10515600" cy="741680"/>
+          <a:off x="838200" y="732950"/>
+          <a:ext cx="10515600" cy="1012799"/>
+        </p:xfrm>
+        <a:graphic>
+          <a:graphicData uri="http://schemas.openxmlformats.org/drawingml/2006/table">
+            <a:tbl>
+              <a:tblPr firstRow="1" bandRow="1">
+                <a:tableStyleId>{5C22544A-7EE6-4342-B048-85BDC9FD1C3A}</a:tableStyleId>
+              </a:tblPr>
+              <a:tblGrid>
+                <a:gridCol w="1752600">
+                  <a:extLst>
+                    <a:ext uri="{9D8B030D-6E8A-4147-A177-3AD203B41FA5}">
+                      <a16:colId xmlns:a16="http://schemas.microsoft.com/office/drawing/2014/main" val="1526623959"/>
+                    </a:ext>
+                  </a:extLst>
+                </a:gridCol>
+                <a:gridCol w="1752600">
+                  <a:extLst>
+                    <a:ext uri="{9D8B030D-6E8A-4147-A177-3AD203B41FA5}">
+                      <a16:colId xmlns:a16="http://schemas.microsoft.com/office/drawing/2014/main" val="2988579106"/>
+                    </a:ext>
+                  </a:extLst>
+                </a:gridCol>
+                <a:gridCol w="1752600">
+                  <a:extLst>
+                    <a:ext uri="{9D8B030D-6E8A-4147-A177-3AD203B41FA5}">
+                      <a16:colId xmlns:a16="http://schemas.microsoft.com/office/drawing/2014/main" val="1994860425"/>
+                    </a:ext>
+                  </a:extLst>
+                </a:gridCol>
+                <a:gridCol w="1752600">
+                  <a:extLst>
+                    <a:ext uri="{9D8B030D-6E8A-4147-A177-3AD203B41FA5}">
+                      <a16:colId xmlns:a16="http://schemas.microsoft.com/office/drawing/2014/main" val="3533840823"/>
+                    </a:ext>
+                  </a:extLst>
+                </a:gridCol>
+                <a:gridCol w="1752600">
+                  <a:extLst>
+                    <a:ext uri="{9D8B030D-6E8A-4147-A177-3AD203B41FA5}">
+                      <a16:colId xmlns:a16="http://schemas.microsoft.com/office/drawing/2014/main" val="1604916882"/>
+                    </a:ext>
+                  </a:extLst>
+                </a:gridCol>
+                <a:gridCol w="1752600">
+                  <a:extLst>
+                    <a:ext uri="{9D8B030D-6E8A-4147-A177-3AD203B41FA5}">
+                      <a16:colId xmlns:a16="http://schemas.microsoft.com/office/drawing/2014/main" val="2482243882"/>
+                    </a:ext>
+                  </a:extLst>
+                </a:gridCol>
+              </a:tblGrid>
+              <a:tr h="370840">
+                <a:tc>
+                  <a:txBody>
+                    <a:bodyPr/>
+                    <a:lstStyle/>
+                    <a:p>
+                      <a:pPr algn="ctr"/>
+                      <a:r>
+                        <a:rPr lang="en-IN" dirty="0"/>
+                        <a:t>A</a:t>
+                      </a:r>
+                    </a:p>
+                  </a:txBody>
+                  <a:tcPr anchor="ctr"/>
+                </a:tc>
+                <a:tc>
+                  <a:txBody>
+                    <a:bodyPr/>
+                    <a:lstStyle/>
+                    <a:p>
+                      <a:pPr algn="ctr"/>
+                      <a:r>
+                        <a:rPr lang="en-IN"/>
+                        <a:t>V</a:t>
+                      </a:r>
+                    </a:p>
+                  </a:txBody>
+                  <a:tcPr anchor="ctr"/>
+                </a:tc>
+                <a:tc>
+                  <a:txBody>
+                    <a:bodyPr/>
+                    <a:lstStyle/>
+                    <a:p>
+                      <a:pPr algn="ctr"/>
+                      <a:r>
+                        <a:rPr lang="en-IN"/>
+                        <a:t>B</a:t>
+                      </a:r>
+                    </a:p>
+                  </a:txBody>
+                  <a:tcPr anchor="ctr"/>
+                </a:tc>
+                <a:tc>
+                  <a:txBody>
+                    <a:bodyPr/>
+                    <a:lstStyle/>
+                    <a:p>
+                      <a:pPr algn="ctr"/>
+                      <a:r>
+                        <a:rPr lang="en-IN"/>
+                        <a:t>C</a:t>
+                      </a:r>
+                    </a:p>
+                  </a:txBody>
+                  <a:tcPr anchor="ctr"/>
+                </a:tc>
+                <a:tc>
+                  <a:txBody>
+                    <a:bodyPr/>
+                    <a:lstStyle/>
+                    <a:p>
+                      <a:pPr algn="ctr"/>
+                      <a:r>
+                        <a:rPr lang="en-IN"/>
+                        <a:t>D</a:t>
+                      </a:r>
+                    </a:p>
+                  </a:txBody>
+                  <a:tcPr anchor="ctr"/>
+                </a:tc>
+                <a:tc>
+                  <a:txBody>
+                    <a:bodyPr/>
+                    <a:lstStyle/>
+                    <a:p>
+                      <a:pPr algn="ctr"/>
+                      <a:r>
+                        <a:rPr lang="en-US"/>
+                        <a:t>STATUS</a:t>
+                      </a:r>
+                      <a:endParaRPr lang="en-IN"/>
+                    </a:p>
+                  </a:txBody>
+                  <a:tcPr anchor="ctr"/>
+                </a:tc>
+                <a:extLst>
+                  <a:ext uri="{0D108BD9-81ED-4DB2-BD59-A6C34878D82A}">
+                    <a16:rowId xmlns:a16="http://schemas.microsoft.com/office/drawing/2014/main" val="1869212938"/>
+                  </a:ext>
+                </a:extLst>
+              </a:tr>
+              <a:tr h="641959">
+                <a:tc>
+                  <a:txBody>
+                    <a:bodyPr/>
+                    <a:lstStyle/>
+                    <a:p>
+                      <a:pPr algn="ctr"/>
+                      <a:r>
+                        <a:rPr lang="en-US" dirty="0"/>
+                        <a:t>100</a:t>
+                      </a:r>
+                      <a:endParaRPr lang="en-IN" dirty="0"/>
+                    </a:p>
+                  </a:txBody>
+                  <a:tcPr anchor="ctr"/>
+                </a:tc>
+                <a:tc>
+                  <a:txBody>
+                    <a:bodyPr/>
+                    <a:lstStyle/>
+                    <a:p>
+                      <a:pPr algn="ctr"/>
+                      <a:r>
+                        <a:rPr lang="en-IN"/>
+                        <a:t>23</a:t>
+                      </a:r>
+                    </a:p>
+                  </a:txBody>
+                  <a:tcPr anchor="ctr"/>
+                </a:tc>
+                <a:tc>
+                  <a:txBody>
+                    <a:bodyPr/>
+                    <a:lstStyle/>
+                    <a:p>
+                      <a:pPr algn="ctr"/>
+                      <a:r>
+                        <a:rPr lang="en-IN" dirty="0"/>
+                        <a:t>24</a:t>
+                      </a:r>
+                    </a:p>
+                  </a:txBody>
+                  <a:tcPr anchor="ctr"/>
+                </a:tc>
+                <a:tc>
+                  <a:txBody>
+                    <a:bodyPr/>
+                    <a:lstStyle/>
+                    <a:p>
+                      <a:pPr algn="ctr"/>
+                      <a:r>
+                        <a:rPr lang="en-IN"/>
+                        <a:t>34</a:t>
+                      </a:r>
+                    </a:p>
+                  </a:txBody>
+                  <a:tcPr anchor="ctr"/>
+                </a:tc>
+                <a:tc>
+                  <a:txBody>
+                    <a:bodyPr/>
+                    <a:lstStyle/>
+                    <a:p>
+                      <a:pPr algn="ctr"/>
+                      <a:r>
+                        <a:rPr lang="en-IN" dirty="0"/>
+                        <a:t>30</a:t>
+                      </a:r>
+                    </a:p>
+                  </a:txBody>
+                  <a:tcPr anchor="ctr"/>
+                </a:tc>
+                <a:tc>
+                  <a:txBody>
+                    <a:bodyPr/>
+                    <a:lstStyle/>
+                    <a:p>
+                      <a:pPr algn="ctr"/>
+                      <a:r>
+                        <a:rPr lang="en-US" dirty="0"/>
+                        <a:t>S</a:t>
+                      </a:r>
+                      <a:endParaRPr lang="en-IN" dirty="0"/>
+                    </a:p>
+                  </a:txBody>
+                  <a:tcPr anchor="ctr"/>
+                </a:tc>
+                <a:extLst>
+                  <a:ext uri="{0D108BD9-81ED-4DB2-BD59-A6C34878D82A}">
+                    <a16:rowId xmlns:a16="http://schemas.microsoft.com/office/drawing/2014/main" val="2255589700"/>
+                  </a:ext>
+                </a:extLst>
+              </a:tr>
+            </a:tbl>
+          </a:graphicData>
+        </a:graphic>
+      </p:graphicFrame>
+      <p:sp>
+        <p:nvSpPr>
+          <p:cNvPr id="3" name="TextBox 2">
+            <a:extLst>
+              <a:ext uri="{FF2B5EF4-FFF2-40B4-BE49-F238E27FC236}">
+                <a16:creationId xmlns:a16="http://schemas.microsoft.com/office/drawing/2014/main" id="{61BEA5E1-63B7-D019-B728-2339B40B412A}"/>
+              </a:ext>
+            </a:extLst>
+          </p:cNvPr>
+          <p:cNvSpPr txBox="1"/>
+          <p:nvPr/>
+        </p:nvSpPr>
+        <p:spPr>
+          <a:xfrm>
+            <a:off x="838200" y="-4207"/>
+            <a:ext cx="3621024" cy="369332"/>
+          </a:xfrm>
+          <a:prstGeom prst="rect">
+            <a:avLst/>
+          </a:prstGeom>
+          <a:noFill/>
+        </p:spPr>
+        <p:txBody>
+          <a:bodyPr wrap="square" rtlCol="0">
+            <a:spAutoFit/>
+          </a:bodyPr>
+          <a:lstStyle/>
+          <a:p>
+            <a:r>
+              <a:rPr lang="en-IN"/>
+              <a:t>Google</a:t>
+            </a:r>
+          </a:p>
+        </p:txBody>
+      </p:sp>
+      <p:graphicFrame>
+        <p:nvGraphicFramePr>
+          <p:cNvPr id="7" name="Table2">
+            <a:extLst>
+              <a:ext uri="{FF2B5EF4-FFF2-40B4-BE49-F238E27FC236}">
+                <a16:creationId xmlns:a16="http://schemas.microsoft.com/office/drawing/2014/main" id="{9C93AABA-0485-1183-C414-51383DDB1C75}"/>
+              </a:ext>
+            </a:extLst>
+          </p:cNvPr>
+          <p:cNvGraphicFramePr>
+            <a:graphicFrameLocks/>
+          </p:cNvGraphicFramePr>
+          <p:nvPr>
+            <p:extLst>
+              <p:ext uri="{D42A27DB-BD31-4B8C-83A1-F6EECF244321}">
+                <p14:modId xmlns:p14="http://schemas.microsoft.com/office/powerpoint/2010/main" val="2384673608"/>
+              </p:ext>
+            </p:extLst>
+          </p:nvPr>
+        </p:nvGraphicFramePr>
+        <p:xfrm>
+          <a:off x="838200" y="5745480"/>
+          <a:ext cx="10515600" cy="1112520"/>
         </p:xfrm>
         <a:graphic>
           <a:graphicData uri="http://schemas.openxmlformats.org/drawingml/2006/table">
@@ -5627,7 +7900,7 @@
                 <a:gridCol w="2103120">
                   <a:extLst>
                     <a:ext uri="{9D8B030D-6E8A-4147-A177-3AD203B41FA5}">
-                      <a16:colId xmlns:a16="http://schemas.microsoft.com/office/drawing/2014/main" val="2988579106"/>
+                      <a16:colId xmlns:a16="http://schemas.microsoft.com/office/drawing/2014/main" val="1036110465"/>
                     </a:ext>
                   </a:extLst>
                 </a:gridCol>
@@ -5654,15 +7927,26 @@
                 </a:gridCol>
               </a:tblGrid>
               <a:tr h="370840">
-                <a:tc>
+                <a:tc gridSpan="2">
                   <a:txBody>
                     <a:bodyPr/>
                     <a:lstStyle/>
                     <a:p>
+                      <a:pPr algn="ctr"/>
                       <a:r>
-                        <a:rPr lang="en-IN" dirty="0"/>
-                        <a:t>A</a:t>
+                        <a:rPr lang="en-IN"/>
+                        <a:t>test</a:t>
                       </a:r>
+                    </a:p>
+                  </a:txBody>
+                  <a:tcPr/>
+                </a:tc>
+                <a:tc hMerge="1">
+                  <a:txBody>
+                    <a:bodyPr/>
+                    <a:lstStyle/>
+                    <a:p>
+                      <a:endParaRPr lang="en-IN"/>
                     </a:p>
                   </a:txBody>
                   <a:tcPr/>
@@ -5672,21 +7956,9 @@
                     <a:bodyPr/>
                     <a:lstStyle/>
                     <a:p>
+                      <a:pPr algn="ctr"/>
                       <a:r>
-                        <a:rPr lang="en-IN" dirty="0"/>
-                        <a:t>V</a:t>
-                      </a:r>
-                    </a:p>
-                  </a:txBody>
-                  <a:tcPr/>
-                </a:tc>
-                <a:tc>
-                  <a:txBody>
-                    <a:bodyPr/>
-                    <a:lstStyle/>
-                    <a:p>
-                      <a:r>
-                        <a:rPr lang="en-IN" dirty="0"/>
+                        <a:rPr lang="en-IN"/>
                         <a:t>B</a:t>
                       </a:r>
                     </a:p>
@@ -5698,8 +7970,9 @@
                     <a:bodyPr/>
                     <a:lstStyle/>
                     <a:p>
+                      <a:pPr algn="ctr"/>
                       <a:r>
-                        <a:rPr lang="en-IN" dirty="0"/>
+                        <a:rPr lang="en-IN"/>
                         <a:t>C</a:t>
                       </a:r>
                     </a:p>
@@ -5711,8 +7984,9 @@
                     <a:bodyPr/>
                     <a:lstStyle/>
                     <a:p>
+                      <a:pPr algn="ctr"/>
                       <a:r>
-                        <a:rPr lang="en-IN" dirty="0"/>
+                        <a:rPr lang="en-IN"/>
                         <a:t>D</a:t>
                       </a:r>
                     </a:p>
@@ -5726,15 +8000,26 @@
                 </a:extLst>
               </a:tr>
               <a:tr h="370840">
-                <a:tc>
+                <a:tc gridSpan="2">
                   <a:txBody>
                     <a:bodyPr/>
                     <a:lstStyle/>
                     <a:p>
+                      <a:pPr algn="ctr"/>
                       <a:r>
                         <a:rPr lang="en-IN" dirty="0"/>
                         <a:t>100</a:t>
                       </a:r>
+                    </a:p>
+                  </a:txBody>
+                  <a:tcPr/>
+                </a:tc>
+                <a:tc hMerge="1">
+                  <a:txBody>
+                    <a:bodyPr/>
+                    <a:lstStyle/>
+                    <a:p>
+                      <a:endParaRPr lang="en-IN"/>
                     </a:p>
                   </a:txBody>
                   <a:tcPr/>
@@ -5744,21 +8029,9 @@
                     <a:bodyPr/>
                     <a:lstStyle/>
                     <a:p>
+                      <a:pPr algn="ctr"/>
                       <a:r>
-                        <a:rPr lang="en-IN" dirty="0"/>
-                        <a:t>23</a:t>
-                      </a:r>
-                    </a:p>
-                  </a:txBody>
-                  <a:tcPr/>
-                </a:tc>
-                <a:tc>
-                  <a:txBody>
-                    <a:bodyPr/>
-                    <a:lstStyle/>
-                    <a:p>
-                      <a:r>
-                        <a:rPr lang="en-IN" dirty="0"/>
+                        <a:rPr lang="en-IN"/>
                         <a:t>24</a:t>
                       </a:r>
                     </a:p>
@@ -5770,8 +8043,9 @@
                     <a:bodyPr/>
                     <a:lstStyle/>
                     <a:p>
+                      <a:pPr algn="ctr"/>
                       <a:r>
-                        <a:rPr lang="en-IN" dirty="0"/>
+                        <a:rPr lang="en-IN"/>
                         <a:t>34</a:t>
                       </a:r>
                     </a:p>
@@ -5783,8 +8057,9 @@
                     <a:bodyPr/>
                     <a:lstStyle/>
                     <a:p>
+                      <a:pPr algn="ctr"/>
                       <a:r>
-                        <a:rPr lang="en-IN" dirty="0"/>
+                        <a:rPr lang="en-IN"/>
                         <a:t>53</a:t>
                       </a:r>
                     </a:p>
@@ -5797,16 +8072,463 @@
                   </a:ext>
                 </a:extLst>
               </a:tr>
+              <a:tr h="370840">
+                <a:tc>
+                  <a:txBody>
+                    <a:bodyPr/>
+                    <a:lstStyle/>
+                    <a:p>
+                      <a:pPr algn="ctr"/>
+                      <a:r>
+                        <a:rPr lang="en-US" dirty="0"/>
+                        <a:t>55</a:t>
+                      </a:r>
+                      <a:endParaRPr lang="en-IN" dirty="0"/>
+                    </a:p>
+                  </a:txBody>
+                  <a:tcPr/>
+                </a:tc>
+                <a:tc>
+                  <a:txBody>
+                    <a:bodyPr/>
+                    <a:lstStyle/>
+                    <a:p>
+                      <a:pPr algn="ctr"/>
+                      <a:r>
+                        <a:rPr lang="en-US"/>
+                        <a:t>45</a:t>
+                      </a:r>
+                      <a:endParaRPr lang="en-IN"/>
+                    </a:p>
+                  </a:txBody>
+                  <a:tcPr/>
+                </a:tc>
+                <a:tc>
+                  <a:txBody>
+                    <a:bodyPr/>
+                    <a:lstStyle/>
+                    <a:p>
+                      <a:pPr algn="ctr"/>
+                      <a:r>
+                        <a:rPr lang="en-US" err="1"/>
+                        <a:t>qqqwet</a:t>
+                      </a:r>
+                      <a:endParaRPr lang="en-IN"/>
+                    </a:p>
+                  </a:txBody>
+                  <a:tcPr/>
+                </a:tc>
+                <a:tc>
+                  <a:txBody>
+                    <a:bodyPr/>
+                    <a:lstStyle/>
+                    <a:p>
+                      <a:pPr algn="ctr"/>
+                      <a:endParaRPr lang="en-IN"/>
+                    </a:p>
+                  </a:txBody>
+                  <a:tcPr/>
+                </a:tc>
+                <a:tc>
+                  <a:txBody>
+                    <a:bodyPr/>
+                    <a:lstStyle/>
+                    <a:p>
+                      <a:pPr algn="ctr"/>
+                      <a:endParaRPr lang="en-IN" dirty="0"/>
+                    </a:p>
+                  </a:txBody>
+                  <a:tcPr/>
+                </a:tc>
+                <a:extLst>
+                  <a:ext uri="{0D108BD9-81ED-4DB2-BD59-A6C34878D82A}">
+                    <a16:rowId xmlns:a16="http://schemas.microsoft.com/office/drawing/2014/main" val="2462398921"/>
+                  </a:ext>
+                </a:extLst>
+              </a:tr>
             </a:tbl>
           </a:graphicData>
         </a:graphic>
       </p:graphicFrame>
       <p:sp>
         <p:nvSpPr>
-          <p:cNvPr id="3" name="TextBox 2">
+          <p:cNvPr id="4" name="Shape01">
             <a:extLst>
               <a:ext uri="{FF2B5EF4-FFF2-40B4-BE49-F238E27FC236}">
-                <a16:creationId xmlns:a16="http://schemas.microsoft.com/office/drawing/2014/main" id="{61BEA5E1-63B7-D019-B728-2339B40B412A}"/>
+                <a16:creationId xmlns:a16="http://schemas.microsoft.com/office/drawing/2014/main" id="{3693A6A3-E2A6-FE4E-5729-75F6CA7C3D56}"/>
+              </a:ext>
+            </a:extLst>
+          </p:cNvPr>
+          <p:cNvSpPr/>
+          <p:nvPr/>
+        </p:nvSpPr>
+        <p:spPr>
+          <a:xfrm>
+            <a:off x="3043418" y="182301"/>
+            <a:ext cx="287274" cy="304800"/>
+          </a:xfrm>
+          <a:prstGeom prst="ellipse">
+            <a:avLst/>
+          </a:prstGeom>
+        </p:spPr>
+        <p:style>
+          <a:lnRef idx="2">
+            <a:schemeClr val="accent6">
+              <a:shade val="15000"/>
+            </a:schemeClr>
+          </a:lnRef>
+          <a:fillRef idx="1">
+            <a:schemeClr val="accent6"/>
+          </a:fillRef>
+          <a:effectRef idx="0">
+            <a:schemeClr val="accent6"/>
+          </a:effectRef>
+          <a:fontRef idx="minor">
+            <a:schemeClr val="lt1"/>
+          </a:fontRef>
+        </p:style>
+        <p:txBody>
+          <a:bodyPr lIns="91440" tIns="45720" rIns="91440" bIns="45720" rtlCol="0" anchor="ctr"/>
+          <a:lstStyle/>
+          <a:p>
+            <a:pPr algn="ctr"/>
+            <a:endParaRPr lang="en-IN" dirty="0">
+              <a:ea typeface="Calibri"/>
+              <a:cs typeface="Calibri"/>
+            </a:endParaRPr>
+          </a:p>
+        </p:txBody>
+      </p:sp>
+      <p:sp>
+        <p:nvSpPr>
+          <p:cNvPr id="8" name="Shape02">
+            <a:extLst>
+              <a:ext uri="{FF2B5EF4-FFF2-40B4-BE49-F238E27FC236}">
+                <a16:creationId xmlns:a16="http://schemas.microsoft.com/office/drawing/2014/main" id="{EAB81D09-6F97-AF14-0D2D-73C35EC0AB38}"/>
+              </a:ext>
+            </a:extLst>
+          </p:cNvPr>
+          <p:cNvSpPr/>
+          <p:nvPr/>
+        </p:nvSpPr>
+        <p:spPr>
+          <a:xfrm>
+            <a:off x="3727410" y="181457"/>
+            <a:ext cx="287274" cy="304800"/>
+          </a:xfrm>
+          <a:prstGeom prst="ellipse">
+            <a:avLst/>
+          </a:prstGeom>
+        </p:spPr>
+        <p:style>
+          <a:lnRef idx="2">
+            <a:schemeClr val="accent2">
+              <a:shade val="15000"/>
+            </a:schemeClr>
+          </a:lnRef>
+          <a:fillRef idx="1">
+            <a:schemeClr val="accent2"/>
+          </a:fillRef>
+          <a:effectRef idx="0">
+            <a:schemeClr val="accent2"/>
+          </a:effectRef>
+          <a:fontRef idx="minor">
+            <a:schemeClr val="lt1"/>
+          </a:fontRef>
+        </p:style>
+        <p:txBody>
+          <a:bodyPr lIns="91440" tIns="45720" rIns="91440" bIns="45720" rtlCol="0" anchor="ctr"/>
+          <a:lstStyle/>
+          <a:p>
+            <a:pPr algn="ctr"/>
+            <a:endParaRPr lang="en-IN" dirty="0">
+              <a:ea typeface="Calibri"/>
+              <a:cs typeface="Calibri"/>
+            </a:endParaRPr>
+          </a:p>
+        </p:txBody>
+      </p:sp>
+      <p:sp>
+        <p:nvSpPr>
+          <p:cNvPr id="10" name="Shape03">
+            <a:extLst>
+              <a:ext uri="{FF2B5EF4-FFF2-40B4-BE49-F238E27FC236}">
+                <a16:creationId xmlns:a16="http://schemas.microsoft.com/office/drawing/2014/main" id="{94BE44B0-3A2D-FC89-DB70-1072E5444FE9}"/>
+              </a:ext>
+            </a:extLst>
+          </p:cNvPr>
+          <p:cNvSpPr/>
+          <p:nvPr/>
+        </p:nvSpPr>
+        <p:spPr>
+          <a:xfrm>
+            <a:off x="4313663" y="178564"/>
+            <a:ext cx="287274" cy="304800"/>
+          </a:xfrm>
+          <a:prstGeom prst="ellipse">
+            <a:avLst/>
+          </a:prstGeom>
+          <a:solidFill>
+            <a:srgbClr val="00B0F0"/>
+          </a:solidFill>
+        </p:spPr>
+        <p:style>
+          <a:lnRef idx="2">
+            <a:schemeClr val="accent6">
+              <a:shade val="15000"/>
+            </a:schemeClr>
+          </a:lnRef>
+          <a:fillRef idx="1">
+            <a:schemeClr val="accent6"/>
+          </a:fillRef>
+          <a:effectRef idx="0">
+            <a:schemeClr val="accent6"/>
+          </a:effectRef>
+          <a:fontRef idx="minor">
+            <a:schemeClr val="lt1"/>
+          </a:fontRef>
+        </p:style>
+        <p:txBody>
+          <a:bodyPr lIns="91440" tIns="45720" rIns="91440" bIns="45720" rtlCol="0" anchor="ctr"/>
+          <a:lstStyle/>
+          <a:p>
+            <a:pPr algn="ctr"/>
+            <a:endParaRPr lang="en-IN" dirty="0">
+              <a:ea typeface="Calibri"/>
+              <a:cs typeface="Calibri"/>
+            </a:endParaRPr>
+          </a:p>
+        </p:txBody>
+      </p:sp>
+      <p:sp>
+        <p:nvSpPr>
+          <p:cNvPr id="6" name="Shape04">
+            <a:extLst>
+              <a:ext uri="{FF2B5EF4-FFF2-40B4-BE49-F238E27FC236}">
+                <a16:creationId xmlns:a16="http://schemas.microsoft.com/office/drawing/2014/main" id="{92B0CC66-1A22-3704-4B85-F2E218CC1DB7}"/>
+              </a:ext>
+            </a:extLst>
+          </p:cNvPr>
+          <p:cNvSpPr/>
+          <p:nvPr/>
+        </p:nvSpPr>
+        <p:spPr>
+          <a:xfrm>
+            <a:off x="4873105" y="178563"/>
+            <a:ext cx="287274" cy="304800"/>
+          </a:xfrm>
+          <a:prstGeom prst="ellipse">
+            <a:avLst/>
+          </a:prstGeom>
+          <a:solidFill>
+            <a:srgbClr val="FFC000"/>
+          </a:solidFill>
+        </p:spPr>
+        <p:style>
+          <a:lnRef idx="2">
+            <a:schemeClr val="accent6">
+              <a:shade val="15000"/>
+            </a:schemeClr>
+          </a:lnRef>
+          <a:fillRef idx="1">
+            <a:schemeClr val="accent6"/>
+          </a:fillRef>
+          <a:effectRef idx="0">
+            <a:schemeClr val="accent6"/>
+          </a:effectRef>
+          <a:fontRef idx="minor">
+            <a:schemeClr val="lt1"/>
+          </a:fontRef>
+        </p:style>
+        <p:txBody>
+          <a:bodyPr lIns="91440" tIns="45720" rIns="91440" bIns="45720" rtlCol="0" anchor="ctr"/>
+          <a:lstStyle/>
+          <a:p>
+            <a:pPr algn="ctr"/>
+            <a:endParaRPr lang="en-IN" dirty="0">
+              <a:ea typeface="Calibri"/>
+              <a:cs typeface="Calibri"/>
+            </a:endParaRPr>
+          </a:p>
+        </p:txBody>
+      </p:sp>
+      <p:sp>
+        <p:nvSpPr>
+          <p:cNvPr id="9" name="Shape05">
+            <a:extLst>
+              <a:ext uri="{FF2B5EF4-FFF2-40B4-BE49-F238E27FC236}">
+                <a16:creationId xmlns:a16="http://schemas.microsoft.com/office/drawing/2014/main" id="{DEEA9499-0AAE-C967-31EB-0E066BD48ABC}"/>
+              </a:ext>
+            </a:extLst>
+          </p:cNvPr>
+          <p:cNvSpPr/>
+          <p:nvPr/>
+        </p:nvSpPr>
+        <p:spPr>
+          <a:xfrm>
+            <a:off x="5403612" y="178564"/>
+            <a:ext cx="287274" cy="304800"/>
+          </a:xfrm>
+          <a:prstGeom prst="ellipse">
+            <a:avLst/>
+          </a:prstGeom>
+          <a:solidFill>
+            <a:srgbClr val="7030A0"/>
+          </a:solidFill>
+        </p:spPr>
+        <p:style>
+          <a:lnRef idx="2">
+            <a:schemeClr val="accent6">
+              <a:shade val="15000"/>
+            </a:schemeClr>
+          </a:lnRef>
+          <a:fillRef idx="1">
+            <a:schemeClr val="accent6"/>
+          </a:fillRef>
+          <a:effectRef idx="0">
+            <a:schemeClr val="accent6"/>
+          </a:effectRef>
+          <a:fontRef idx="minor">
+            <a:schemeClr val="lt1"/>
+          </a:fontRef>
+        </p:style>
+        <p:txBody>
+          <a:bodyPr lIns="91440" tIns="45720" rIns="91440" bIns="45720" rtlCol="0" anchor="ctr"/>
+          <a:lstStyle/>
+          <a:p>
+            <a:pPr algn="ctr"/>
+            <a:endParaRPr lang="en-IN" dirty="0">
+              <a:ea typeface="Calibri"/>
+              <a:cs typeface="Calibri"/>
+            </a:endParaRPr>
+          </a:p>
+        </p:txBody>
+      </p:sp>
+      <p:sp>
+        <p:nvSpPr>
+          <p:cNvPr id="11" name="Shape06">
+            <a:extLst>
+              <a:ext uri="{FF2B5EF4-FFF2-40B4-BE49-F238E27FC236}">
+                <a16:creationId xmlns:a16="http://schemas.microsoft.com/office/drawing/2014/main" id="{BB6AB5BE-5F58-2384-C0AA-46EADE997667}"/>
+              </a:ext>
+            </a:extLst>
+          </p:cNvPr>
+          <p:cNvSpPr/>
+          <p:nvPr/>
+        </p:nvSpPr>
+        <p:spPr>
+          <a:xfrm>
+            <a:off x="5953409" y="178563"/>
+            <a:ext cx="287274" cy="304800"/>
+          </a:xfrm>
+          <a:prstGeom prst="ellipse">
+            <a:avLst/>
+          </a:prstGeom>
+          <a:solidFill>
+            <a:srgbClr val="002060"/>
+          </a:solidFill>
+        </p:spPr>
+        <p:style>
+          <a:lnRef idx="2">
+            <a:schemeClr val="accent6">
+              <a:shade val="15000"/>
+            </a:schemeClr>
+          </a:lnRef>
+          <a:fillRef idx="1">
+            <a:schemeClr val="accent6"/>
+          </a:fillRef>
+          <a:effectRef idx="0">
+            <a:schemeClr val="accent6"/>
+          </a:effectRef>
+          <a:fontRef idx="minor">
+            <a:schemeClr val="lt1"/>
+          </a:fontRef>
+        </p:style>
+        <p:txBody>
+          <a:bodyPr lIns="91440" tIns="45720" rIns="91440" bIns="45720" rtlCol="0" anchor="ctr"/>
+          <a:lstStyle/>
+          <a:p>
+            <a:pPr algn="ctr"/>
+            <a:endParaRPr lang="en-IN" dirty="0">
+              <a:ea typeface="Calibri"/>
+              <a:cs typeface="Calibri"/>
+            </a:endParaRPr>
+          </a:p>
+        </p:txBody>
+      </p:sp>
+    </p:spTree>
+    <p:extLst>
+      <p:ext uri="{BB962C8B-B14F-4D97-AF65-F5344CB8AC3E}">
+        <p14:creationId xmlns:p14="http://schemas.microsoft.com/office/powerpoint/2010/main" val="3046703408"/>
+      </p:ext>
+    </p:extLst>
+  </p:cSld>
+  <p:clrMapOvr>
+    <a:masterClrMapping/>
+  </p:clrMapOvr>
+</p:sld>
+</file>
+
+<file path=ppt/slides/slide4.xml><?xml version="1.0" encoding="utf-8"?>
+<p:sld xmlns:a="http://schemas.openxmlformats.org/drawingml/2006/main" xmlns:r="http://schemas.openxmlformats.org/officeDocument/2006/relationships" xmlns:p="http://schemas.openxmlformats.org/presentationml/2006/main">
+  <p:cSld>
+    <p:spTree>
+      <p:nvGrpSpPr>
+        <p:cNvPr id="1" name="">
+          <a:extLst>
+            <a:ext uri="{FF2B5EF4-FFF2-40B4-BE49-F238E27FC236}">
+              <a16:creationId xmlns:a16="http://schemas.microsoft.com/office/drawing/2014/main" id="{F312459A-1B0A-6E6F-F276-54D5C518EC17}"/>
+            </a:ext>
+          </a:extLst>
+        </p:cNvPr>
+        <p:cNvGrpSpPr/>
+        <p:nvPr/>
+      </p:nvGrpSpPr>
+      <p:grpSpPr>
+        <a:xfrm>
+          <a:off x="0" y="0"/>
+          <a:ext cx="0" cy="0"/>
+          <a:chOff x="0" y="0"/>
+          <a:chExt cx="0" cy="0"/>
+        </a:xfrm>
+      </p:grpSpPr>
+      <p:graphicFrame>
+        <p:nvGraphicFramePr>
+          <p:cNvPr id="12" name="Label Chart">
+            <a:extLst>
+              <a:ext uri="{FF2B5EF4-FFF2-40B4-BE49-F238E27FC236}">
+                <a16:creationId xmlns:a16="http://schemas.microsoft.com/office/drawing/2014/main" id="{5C45F2CF-DBD3-6DBD-9D94-4A468569840F}"/>
+              </a:ext>
+            </a:extLst>
+          </p:cNvPr>
+          <p:cNvGraphicFramePr>
+            <a:graphicFrameLocks noGrp="1"/>
+          </p:cNvGraphicFramePr>
+          <p:nvPr>
+            <p:ph idx="1"/>
+            <p:extLst>
+              <p:ext uri="{D42A27DB-BD31-4B8C-83A1-F6EECF244321}">
+                <p14:modId xmlns:p14="http://schemas.microsoft.com/office/powerpoint/2010/main" val="1630066042"/>
+              </p:ext>
+            </p:extLst>
+          </p:nvPr>
+        </p:nvGraphicFramePr>
+        <p:xfrm>
+          <a:off x="767862" y="323118"/>
+          <a:ext cx="10515600" cy="5829300"/>
+        </p:xfrm>
+        <a:graphic>
+          <a:graphicData uri="http://schemas.openxmlformats.org/drawingml/2006/chart">
+            <c:chart xmlns:c="http://schemas.openxmlformats.org/drawingml/2006/chart" xmlns:r="http://schemas.openxmlformats.org/officeDocument/2006/relationships" r:id="rId2"/>
+          </a:graphicData>
+        </a:graphic>
+      </p:graphicFrame>
+      <p:sp>
+        <p:nvSpPr>
+          <p:cNvPr id="2" name="Series 1">
+            <a:extLst>
+              <a:ext uri="{FF2B5EF4-FFF2-40B4-BE49-F238E27FC236}">
+                <a16:creationId xmlns:a16="http://schemas.microsoft.com/office/drawing/2014/main" id="{528C6C22-A610-78C4-A2AD-7D0567240895}"/>
               </a:ext>
             </a:extLst>
           </p:cNvPr>
@@ -5815,8 +8537,8 @@
         </p:nvSpPr>
         <p:spPr>
           <a:xfrm>
-            <a:off x="2121408" y="3931920"/>
-            <a:ext cx="3621024" cy="369332"/>
+            <a:off x="451521" y="323118"/>
+            <a:ext cx="914033" cy="369332"/>
           </a:xfrm>
           <a:prstGeom prst="rect">
             <a:avLst/>
@@ -5824,14 +8546,125 @@
           <a:noFill/>
         </p:spPr>
         <p:txBody>
-          <a:bodyPr wrap="square" rtlCol="0">
+          <a:bodyPr wrap="none" rtlCol="0">
             <a:spAutoFit/>
           </a:bodyPr>
           <a:lstStyle/>
           <a:p>
             <a:r>
-              <a:rPr lang="en-IN" dirty="0"/>
-              <a:t>Google</a:t>
+              <a:rPr lang="en-US">
+                <a:latin typeface="Adobe Garamond Pro Bold" panose="02020702060506020403" pitchFamily="18" charset="0"/>
+              </a:rPr>
+              <a:t>Series 1</a:t>
+            </a:r>
+          </a:p>
+        </p:txBody>
+      </p:sp>
+      <p:sp>
+        <p:nvSpPr>
+          <p:cNvPr id="3" name="Series 2">
+            <a:extLst>
+              <a:ext uri="{FF2B5EF4-FFF2-40B4-BE49-F238E27FC236}">
+                <a16:creationId xmlns:a16="http://schemas.microsoft.com/office/drawing/2014/main" id="{69A49453-F4CD-A2C1-CCB9-8F43FA8E4533}"/>
+              </a:ext>
+            </a:extLst>
+          </p:cNvPr>
+          <p:cNvSpPr txBox="1"/>
+          <p:nvPr/>
+        </p:nvSpPr>
+        <p:spPr>
+          <a:xfrm>
+            <a:off x="2233246" y="215396"/>
+            <a:ext cx="1479892" cy="584775"/>
+          </a:xfrm>
+          <a:prstGeom prst="rect">
+            <a:avLst/>
+          </a:prstGeom>
+          <a:noFill/>
+        </p:spPr>
+        <p:txBody>
+          <a:bodyPr wrap="none" rtlCol="0">
+            <a:spAutoFit/>
+          </a:bodyPr>
+          <a:lstStyle/>
+          <a:p>
+            <a:r>
+              <a:rPr lang="en-US" sz="3200"/>
+              <a:t>Series 2</a:t>
+            </a:r>
+          </a:p>
+        </p:txBody>
+      </p:sp>
+      <p:sp>
+        <p:nvSpPr>
+          <p:cNvPr id="4" name="Series 3">
+            <a:extLst>
+              <a:ext uri="{FF2B5EF4-FFF2-40B4-BE49-F238E27FC236}">
+                <a16:creationId xmlns:a16="http://schemas.microsoft.com/office/drawing/2014/main" id="{2A05536A-4FFD-8E7E-9399-0D60836393AF}"/>
+              </a:ext>
+            </a:extLst>
+          </p:cNvPr>
+          <p:cNvSpPr txBox="1"/>
+          <p:nvPr/>
+        </p:nvSpPr>
+        <p:spPr>
+          <a:xfrm>
+            <a:off x="4029479" y="323117"/>
+            <a:ext cx="914033" cy="369332"/>
+          </a:xfrm>
+          <a:prstGeom prst="rect">
+            <a:avLst/>
+          </a:prstGeom>
+          <a:noFill/>
+        </p:spPr>
+        <p:txBody>
+          <a:bodyPr wrap="none" rtlCol="0">
+            <a:spAutoFit/>
+          </a:bodyPr>
+          <a:lstStyle/>
+          <a:p>
+            <a:r>
+              <a:rPr lang="en-US"/>
+              <a:t>Series 3</a:t>
+            </a:r>
+          </a:p>
+        </p:txBody>
+      </p:sp>
+      <p:sp>
+        <p:nvSpPr>
+          <p:cNvPr id="5" name="Series 4">
+            <a:extLst>
+              <a:ext uri="{FF2B5EF4-FFF2-40B4-BE49-F238E27FC236}">
+                <a16:creationId xmlns:a16="http://schemas.microsoft.com/office/drawing/2014/main" id="{7DC1B613-8D39-9EBB-3EDF-AB17022F34BA}"/>
+              </a:ext>
+            </a:extLst>
+          </p:cNvPr>
+          <p:cNvSpPr txBox="1"/>
+          <p:nvPr/>
+        </p:nvSpPr>
+        <p:spPr>
+          <a:xfrm>
+            <a:off x="5547945" y="430839"/>
+            <a:ext cx="696024" cy="369332"/>
+          </a:xfrm>
+          <a:prstGeom prst="rect">
+            <a:avLst/>
+          </a:prstGeom>
+          <a:noFill/>
+        </p:spPr>
+        <p:txBody>
+          <a:bodyPr wrap="none" rtlCol="0">
+            <a:spAutoFit/>
+          </a:bodyPr>
+          <a:lstStyle/>
+          <a:p>
+            <a:r>
+              <a:rPr lang="en-US" sz="1100"/>
+              <a:t>Series</a:t>
+            </a:r>
+            <a:r>
+              <a:rPr lang="en-US"/>
+              <a:t> 4</a:t>
             </a:r>
           </a:p>
         </p:txBody>
@@ -5839,7 +8672,739 @@
     </p:spTree>
     <p:extLst>
       <p:ext uri="{BB962C8B-B14F-4D97-AF65-F5344CB8AC3E}">
-        <p14:creationId xmlns:p14="http://schemas.microsoft.com/office/powerpoint/2010/main" val="3046703408"/>
+        <p14:creationId xmlns:p14="http://schemas.microsoft.com/office/powerpoint/2010/main" val="2812630168"/>
+      </p:ext>
+    </p:extLst>
+  </p:cSld>
+  <p:clrMapOvr>
+    <a:masterClrMapping/>
+  </p:clrMapOvr>
+</p:sld>
+</file>
+
+<file path=ppt/slides/slide5.xml><?xml version="1.0" encoding="utf-8"?>
+<p:sld xmlns:a="http://schemas.openxmlformats.org/drawingml/2006/main" xmlns:r="http://schemas.openxmlformats.org/officeDocument/2006/relationships" xmlns:p="http://schemas.openxmlformats.org/presentationml/2006/main">
+  <p:cSld>
+    <p:spTree>
+      <p:nvGrpSpPr>
+        <p:cNvPr id="1" name="">
+          <a:extLst>
+            <a:ext uri="{FF2B5EF4-FFF2-40B4-BE49-F238E27FC236}">
+              <a16:creationId xmlns:a16="http://schemas.microsoft.com/office/drawing/2014/main" id="{7E88BBC3-FCFB-D908-8621-21B4D06A1C4C}"/>
+            </a:ext>
+          </a:extLst>
+        </p:cNvPr>
+        <p:cNvGrpSpPr/>
+        <p:nvPr/>
+      </p:nvGrpSpPr>
+      <p:grpSpPr>
+        <a:xfrm>
+          <a:off x="0" y="0"/>
+          <a:ext cx="0" cy="0"/>
+          <a:chOff x="0" y="0"/>
+          <a:chExt cx="0" cy="0"/>
+        </a:xfrm>
+      </p:grpSpPr>
+      <p:sp>
+        <p:nvSpPr>
+          <p:cNvPr id="3" name="List">
+            <a:extLst>
+              <a:ext uri="{FF2B5EF4-FFF2-40B4-BE49-F238E27FC236}">
+                <a16:creationId xmlns:a16="http://schemas.microsoft.com/office/drawing/2014/main" id="{60020E62-F94D-048C-41EB-CD6F496590D6}"/>
+              </a:ext>
+            </a:extLst>
+          </p:cNvPr>
+          <p:cNvSpPr>
+            <a:spLocks noGrp="1"/>
+          </p:cNvSpPr>
+          <p:nvPr>
+            <p:ph idx="1"/>
+          </p:nvPr>
+        </p:nvSpPr>
+        <p:spPr/>
+        <p:txBody>
+          <a:bodyPr/>
+          <a:lstStyle/>
+          <a:p>
+            <a:r>
+              <a:rPr lang="en-US">
+                <a:latin typeface="Adobe Fan Heiti Std B" panose="020B0700000000000000" pitchFamily="34" charset="-128"/>
+                <a:ea typeface="Adobe Fan Heiti Std B" panose="020B0700000000000000" pitchFamily="34" charset="-128"/>
+              </a:rPr>
+              <a:t>1</a:t>
+            </a:r>
+            <a:r>
+              <a:rPr lang="en-US" baseline="30000">
+                <a:latin typeface="Adobe Fan Heiti Std B" panose="020B0700000000000000" pitchFamily="34" charset="-128"/>
+                <a:ea typeface="Adobe Fan Heiti Std B" panose="020B0700000000000000" pitchFamily="34" charset="-128"/>
+              </a:rPr>
+              <a:t>st</a:t>
+            </a:r>
+            <a:r>
+              <a:rPr lang="en-US">
+                <a:latin typeface="Adobe Fan Heiti Std B" panose="020B0700000000000000" pitchFamily="34" charset="-128"/>
+                <a:ea typeface="Adobe Fan Heiti Std B" panose="020B0700000000000000" pitchFamily="34" charset="-128"/>
+              </a:rPr>
+              <a:t> item</a:t>
+            </a:r>
+          </a:p>
+          <a:p>
+            <a:r>
+              <a:rPr lang="en-US">
+                <a:latin typeface="Adobe Garamond Pro Bold" panose="02020702060506020403" pitchFamily="18" charset="0"/>
+              </a:rPr>
+              <a:t>2</a:t>
+            </a:r>
+            <a:r>
+              <a:rPr lang="en-US" baseline="30000">
+                <a:latin typeface="Adobe Garamond Pro Bold" panose="02020702060506020403" pitchFamily="18" charset="0"/>
+              </a:rPr>
+              <a:t>nd</a:t>
+            </a:r>
+            <a:r>
+              <a:rPr lang="en-US">
+                <a:latin typeface="Adobe Garamond Pro Bold" panose="02020702060506020403" pitchFamily="18" charset="0"/>
+              </a:rPr>
+              <a:t> item</a:t>
+            </a:r>
+          </a:p>
+          <a:p>
+            <a:r>
+              <a:rPr lang="en-US" sz="1600"/>
+              <a:t>3</a:t>
+            </a:r>
+            <a:r>
+              <a:rPr lang="en-US" sz="1600" baseline="30000"/>
+              <a:t>rd</a:t>
+            </a:r>
+            <a:r>
+              <a:rPr lang="en-US" sz="1600"/>
+              <a:t> item</a:t>
+            </a:r>
+            <a:endParaRPr lang="en-IN" sz="1600"/>
+          </a:p>
+        </p:txBody>
+      </p:sp>
+    </p:spTree>
+    <p:extLst>
+      <p:ext uri="{BB962C8B-B14F-4D97-AF65-F5344CB8AC3E}">
+        <p14:creationId xmlns:p14="http://schemas.microsoft.com/office/powerpoint/2010/main" val="4113158550"/>
+      </p:ext>
+    </p:extLst>
+  </p:cSld>
+  <p:clrMapOvr>
+    <a:masterClrMapping/>
+  </p:clrMapOvr>
+</p:sld>
+</file>
+
+<file path=ppt/slides/slide6.xml><?xml version="1.0" encoding="utf-8"?>
+<p:sld xmlns:a="http://schemas.openxmlformats.org/drawingml/2006/main" xmlns:r="http://schemas.openxmlformats.org/officeDocument/2006/relationships" xmlns:p="http://schemas.openxmlformats.org/presentationml/2006/main">
+  <p:cSld>
+    <p:spTree>
+      <p:nvGrpSpPr>
+        <p:cNvPr id="1" name=""/>
+        <p:cNvGrpSpPr/>
+        <p:nvPr/>
+      </p:nvGrpSpPr>
+      <p:grpSpPr>
+        <a:xfrm>
+          <a:off x="0" y="0"/>
+          <a:ext cx="0" cy="0"/>
+          <a:chOff x="0" y="0"/>
+          <a:chExt cx="0" cy="0"/>
+        </a:xfrm>
+      </p:grpSpPr>
+      <p:graphicFrame>
+        <p:nvGraphicFramePr>
+          <p:cNvPr id="4" name="Table">
+            <a:extLst>
+              <a:ext uri="{FF2B5EF4-FFF2-40B4-BE49-F238E27FC236}">
+                <a16:creationId xmlns:a16="http://schemas.microsoft.com/office/drawing/2014/main" id="{FE7BC075-9F6E-28B2-59E8-8F26920BE7E2}"/>
+              </a:ext>
+            </a:extLst>
+          </p:cNvPr>
+          <p:cNvGraphicFramePr>
+            <a:graphicFrameLocks/>
+          </p:cNvGraphicFramePr>
+          <p:nvPr>
+            <p:extLst>
+              <p:ext uri="{D42A27DB-BD31-4B8C-83A1-F6EECF244321}">
+                <p14:modId xmlns:p14="http://schemas.microsoft.com/office/powerpoint/2010/main" val="3500558840"/>
+              </p:ext>
+            </p:extLst>
+          </p:nvPr>
+        </p:nvGraphicFramePr>
+        <p:xfrm>
+          <a:off x="838199" y="573206"/>
+          <a:ext cx="10789696" cy="736600"/>
+        </p:xfrm>
+        <a:graphic>
+          <a:graphicData uri="http://schemas.openxmlformats.org/drawingml/2006/table">
+            <a:tbl>
+              <a:tblPr firstRow="1" bandRow="1">
+                <a:tableStyleId>{5C22544A-7EE6-4342-B048-85BDC9FD1C3A}</a:tableStyleId>
+              </a:tblPr>
+              <a:tblGrid>
+                <a:gridCol w="1348712">
+                  <a:extLst>
+                    <a:ext uri="{9D8B030D-6E8A-4147-A177-3AD203B41FA5}">
+                      <a16:colId xmlns:a16="http://schemas.microsoft.com/office/drawing/2014/main" val="2779847418"/>
+                    </a:ext>
+                  </a:extLst>
+                </a:gridCol>
+                <a:gridCol w="1348712">
+                  <a:extLst>
+                    <a:ext uri="{9D8B030D-6E8A-4147-A177-3AD203B41FA5}">
+                      <a16:colId xmlns:a16="http://schemas.microsoft.com/office/drawing/2014/main" val="1632793384"/>
+                    </a:ext>
+                  </a:extLst>
+                </a:gridCol>
+                <a:gridCol w="1348712">
+                  <a:extLst>
+                    <a:ext uri="{9D8B030D-6E8A-4147-A177-3AD203B41FA5}">
+                      <a16:colId xmlns:a16="http://schemas.microsoft.com/office/drawing/2014/main" val="2032430761"/>
+                    </a:ext>
+                  </a:extLst>
+                </a:gridCol>
+                <a:gridCol w="1348712">
+                  <a:extLst>
+                    <a:ext uri="{9D8B030D-6E8A-4147-A177-3AD203B41FA5}">
+                      <a16:colId xmlns:a16="http://schemas.microsoft.com/office/drawing/2014/main" val="3759091533"/>
+                    </a:ext>
+                  </a:extLst>
+                </a:gridCol>
+                <a:gridCol w="1348712">
+                  <a:extLst>
+                    <a:ext uri="{9D8B030D-6E8A-4147-A177-3AD203B41FA5}">
+                      <a16:colId xmlns:a16="http://schemas.microsoft.com/office/drawing/2014/main" val="3854161084"/>
+                    </a:ext>
+                  </a:extLst>
+                </a:gridCol>
+                <a:gridCol w="1348712">
+                  <a:extLst>
+                    <a:ext uri="{9D8B030D-6E8A-4147-A177-3AD203B41FA5}">
+                      <a16:colId xmlns:a16="http://schemas.microsoft.com/office/drawing/2014/main" val="2580032536"/>
+                    </a:ext>
+                  </a:extLst>
+                </a:gridCol>
+                <a:gridCol w="1348712">
+                  <a:extLst>
+                    <a:ext uri="{9D8B030D-6E8A-4147-A177-3AD203B41FA5}">
+                      <a16:colId xmlns:a16="http://schemas.microsoft.com/office/drawing/2014/main" val="3625072384"/>
+                    </a:ext>
+                  </a:extLst>
+                </a:gridCol>
+                <a:gridCol w="1348712">
+                  <a:extLst>
+                    <a:ext uri="{9D8B030D-6E8A-4147-A177-3AD203B41FA5}">
+                      <a16:colId xmlns:a16="http://schemas.microsoft.com/office/drawing/2014/main" val="1242086109"/>
+                    </a:ext>
+                  </a:extLst>
+                </a:gridCol>
+              </a:tblGrid>
+              <a:tr h="286828">
+                <a:tc gridSpan="2">
+                  <a:txBody>
+                    <a:bodyPr/>
+                    <a:lstStyle/>
+                    <a:p>
+                      <a:r>
+                        <a:rPr lang="en-US" dirty="0"/>
+                        <a:t>Team</a:t>
+                      </a:r>
+                      <a:endParaRPr lang="en-IN" dirty="0"/>
+                    </a:p>
+                  </a:txBody>
+                  <a:tcPr anchor="ctr"/>
+                </a:tc>
+                <a:tc hMerge="1">
+                  <a:txBody>
+                    <a:bodyPr/>
+                    <a:lstStyle/>
+                    <a:p>
+                      <a:endParaRPr lang="en-IN" dirty="0"/>
+                    </a:p>
+                  </a:txBody>
+                  <a:tcPr/>
+                </a:tc>
+                <a:tc>
+                  <a:txBody>
+                    <a:bodyPr/>
+                    <a:lstStyle/>
+                    <a:p>
+                      <a:r>
+                        <a:rPr lang="en-US" dirty="0"/>
+                        <a:t>Name</a:t>
+                      </a:r>
+                      <a:endParaRPr lang="en-IN" dirty="0"/>
+                    </a:p>
+                  </a:txBody>
+                  <a:tcPr anchor="ctr"/>
+                </a:tc>
+                <a:tc>
+                  <a:txBody>
+                    <a:bodyPr/>
+                    <a:lstStyle/>
+                    <a:p>
+                      <a:r>
+                        <a:rPr lang="en-US" dirty="0"/>
+                        <a:t>Role</a:t>
+                      </a:r>
+                      <a:endParaRPr lang="en-IN" dirty="0"/>
+                    </a:p>
+                  </a:txBody>
+                  <a:tcPr anchor="ctr"/>
+                </a:tc>
+                <a:tc>
+                  <a:txBody>
+                    <a:bodyPr/>
+                    <a:lstStyle/>
+                    <a:p>
+                      <a:r>
+                        <a:rPr lang="en-US" dirty="0"/>
+                        <a:t>Description</a:t>
+                      </a:r>
+                      <a:endParaRPr lang="en-IN" dirty="0"/>
+                    </a:p>
+                  </a:txBody>
+                  <a:tcPr anchor="ctr"/>
+                </a:tc>
+                <a:tc>
+                  <a:txBody>
+                    <a:bodyPr/>
+                    <a:lstStyle/>
+                    <a:p>
+                      <a:r>
+                        <a:rPr lang="en-US" dirty="0"/>
+                        <a:t>Value</a:t>
+                      </a:r>
+                      <a:endParaRPr lang="en-IN" dirty="0"/>
+                    </a:p>
+                  </a:txBody>
+                  <a:tcPr anchor="ctr"/>
+                </a:tc>
+                <a:tc gridSpan="2">
+                  <a:txBody>
+                    <a:bodyPr/>
+                    <a:lstStyle/>
+                    <a:p>
+                      <a:pPr algn="ctr"/>
+                      <a:r>
+                        <a:rPr lang="en-US" dirty="0"/>
+                        <a:t>Point</a:t>
+                      </a:r>
+                      <a:endParaRPr lang="en-IN" dirty="0"/>
+                    </a:p>
+                  </a:txBody>
+                  <a:tcPr anchor="ctr"/>
+                </a:tc>
+                <a:tc hMerge="1">
+                  <a:txBody>
+                    <a:bodyPr/>
+                    <a:lstStyle/>
+                    <a:p>
+                      <a:endParaRPr lang="en-IN" dirty="0"/>
+                    </a:p>
+                  </a:txBody>
+                  <a:tcPr/>
+                </a:tc>
+                <a:extLst>
+                  <a:ext uri="{0D108BD9-81ED-4DB2-BD59-A6C34878D82A}">
+                    <a16:rowId xmlns:a16="http://schemas.microsoft.com/office/drawing/2014/main" val="1009083968"/>
+                  </a:ext>
+                </a:extLst>
+              </a:tr>
+              <a:tr h="370840">
+                <a:tc>
+                  <a:txBody>
+                    <a:bodyPr/>
+                    <a:lstStyle/>
+                    <a:p>
+                      <a:r>
+                        <a:rPr lang="en-US" dirty="0">
+                          <a:latin typeface="Algerian" panose="04020705040A02060702" pitchFamily="82" charset="0"/>
+                        </a:rPr>
+                        <a:t>S</a:t>
+                      </a:r>
+                      <a:endParaRPr lang="en-IN" dirty="0">
+                        <a:latin typeface="Algerian" panose="04020705040A02060702" pitchFamily="82" charset="0"/>
+                      </a:endParaRPr>
+                    </a:p>
+                  </a:txBody>
+                  <a:tcPr anchor="ctr"/>
+                </a:tc>
+                <a:tc>
+                  <a:txBody>
+                    <a:bodyPr/>
+                    <a:lstStyle/>
+                    <a:p>
+                      <a:r>
+                        <a:rPr lang="en-US" dirty="0">
+                          <a:latin typeface="Algerian" panose="04020705040A02060702" pitchFamily="82" charset="0"/>
+                        </a:rPr>
+                        <a:t>x</a:t>
+                      </a:r>
+                      <a:endParaRPr lang="en-IN" dirty="0">
+                        <a:latin typeface="Algerian" panose="04020705040A02060702" pitchFamily="82" charset="0"/>
+                      </a:endParaRPr>
+                    </a:p>
+                  </a:txBody>
+                  <a:tcPr anchor="ctr"/>
+                </a:tc>
+                <a:tc>
+                  <a:txBody>
+                    <a:bodyPr/>
+                    <a:lstStyle/>
+                    <a:p>
+                      <a:r>
+                        <a:rPr lang="en-US" dirty="0">
+                          <a:latin typeface="Algerian" panose="04020705040A02060702" pitchFamily="82" charset="0"/>
+                        </a:rPr>
+                        <a:t>A</a:t>
+                      </a:r>
+                      <a:endParaRPr lang="en-IN" dirty="0">
+                        <a:latin typeface="Algerian" panose="04020705040A02060702" pitchFamily="82" charset="0"/>
+                      </a:endParaRPr>
+                    </a:p>
+                  </a:txBody>
+                  <a:tcPr anchor="ctr"/>
+                </a:tc>
+                <a:tc>
+                  <a:txBody>
+                    <a:bodyPr/>
+                    <a:lstStyle/>
+                    <a:p>
+                      <a:r>
+                        <a:rPr lang="en-US" dirty="0">
+                          <a:latin typeface="Algerian" panose="04020705040A02060702" pitchFamily="82" charset="0"/>
+                        </a:rPr>
+                        <a:t>z</a:t>
+                      </a:r>
+                      <a:endParaRPr lang="en-IN" dirty="0">
+                        <a:latin typeface="Algerian" panose="04020705040A02060702" pitchFamily="82" charset="0"/>
+                      </a:endParaRPr>
+                    </a:p>
+                  </a:txBody>
+                  <a:tcPr anchor="ctr"/>
+                </a:tc>
+                <a:tc>
+                  <a:txBody>
+                    <a:bodyPr/>
+                    <a:lstStyle/>
+                    <a:p>
+                      <a:r>
+                        <a:rPr lang="en-US" sz="1800" dirty="0">
+                          <a:latin typeface="Algerian" panose="04020705040A02060702" pitchFamily="82" charset="0"/>
+                        </a:rPr>
+                        <a:t>d</a:t>
+                      </a:r>
+                      <a:endParaRPr lang="en-IN" sz="1800" dirty="0">
+                        <a:latin typeface="Algerian" panose="04020705040A02060702" pitchFamily="82" charset="0"/>
+                      </a:endParaRPr>
+                    </a:p>
+                  </a:txBody>
+                  <a:tcPr anchor="ctr"/>
+                </a:tc>
+                <a:tc>
+                  <a:txBody>
+                    <a:bodyPr/>
+                    <a:lstStyle/>
+                    <a:p>
+                      <a:r>
+                        <a:rPr lang="en-US" dirty="0">
+                          <a:latin typeface="Algerian" panose="04020705040A02060702" pitchFamily="82" charset="0"/>
+                        </a:rPr>
+                        <a:t>a</a:t>
+                      </a:r>
+                      <a:endParaRPr lang="en-IN" dirty="0">
+                        <a:latin typeface="Algerian" panose="04020705040A02060702" pitchFamily="82" charset="0"/>
+                      </a:endParaRPr>
+                    </a:p>
+                  </a:txBody>
+                  <a:tcPr anchor="ctr"/>
+                </a:tc>
+                <a:tc>
+                  <a:txBody>
+                    <a:bodyPr/>
+                    <a:lstStyle/>
+                    <a:p>
+                      <a:r>
+                        <a:rPr lang="en-US" dirty="0">
+                          <a:latin typeface="Algerian" panose="04020705040A02060702" pitchFamily="82" charset="0"/>
+                        </a:rPr>
+                        <a:t>V</a:t>
+                      </a:r>
+                      <a:endParaRPr lang="en-IN" dirty="0">
+                        <a:latin typeface="Algerian" panose="04020705040A02060702" pitchFamily="82" charset="0"/>
+                      </a:endParaRPr>
+                    </a:p>
+                  </a:txBody>
+                  <a:tcPr anchor="ctr"/>
+                </a:tc>
+                <a:tc>
+                  <a:txBody>
+                    <a:bodyPr/>
+                    <a:lstStyle/>
+                    <a:p>
+                      <a:r>
+                        <a:rPr lang="en-US" dirty="0">
+                          <a:latin typeface="Algerian" panose="04020705040A02060702" pitchFamily="82" charset="0"/>
+                        </a:rPr>
+                        <a:t>V</a:t>
+                      </a:r>
+                      <a:endParaRPr lang="en-IN" dirty="0">
+                        <a:latin typeface="Algerian" panose="04020705040A02060702" pitchFamily="82" charset="0"/>
+                      </a:endParaRPr>
+                    </a:p>
+                  </a:txBody>
+                  <a:tcPr anchor="ctr"/>
+                </a:tc>
+                <a:extLst>
+                  <a:ext uri="{0D108BD9-81ED-4DB2-BD59-A6C34878D82A}">
+                    <a16:rowId xmlns:a16="http://schemas.microsoft.com/office/drawing/2014/main" val="3519732806"/>
+                  </a:ext>
+                </a:extLst>
+              </a:tr>
+            </a:tbl>
+          </a:graphicData>
+        </a:graphic>
+      </p:graphicFrame>
+      <p:sp>
+        <p:nvSpPr>
+          <p:cNvPr id="2" name="Team A Logo">
+            <a:extLst>
+              <a:ext uri="{FF2B5EF4-FFF2-40B4-BE49-F238E27FC236}">
+                <a16:creationId xmlns:a16="http://schemas.microsoft.com/office/drawing/2014/main" id="{40CE57F1-956F-4695-F427-6DECEE6DFC90}"/>
+              </a:ext>
+            </a:extLst>
+          </p:cNvPr>
+          <p:cNvSpPr/>
+          <p:nvPr/>
+        </p:nvSpPr>
+        <p:spPr>
+          <a:xfrm>
+            <a:off x="-358439" y="2082600"/>
+            <a:ext cx="716878" cy="814509"/>
+          </a:xfrm>
+          <a:prstGeom prst="rect">
+            <a:avLst/>
+          </a:prstGeom>
+          <a:blipFill dpi="0" rotWithShape="1">
+            <a:blip r:embed="rId2">
+              <a:extLst>
+                <a:ext uri="{28A0092B-C50C-407E-A947-70E740481C1C}">
+                  <a14:useLocalDpi xmlns:a14="http://schemas.microsoft.com/office/drawing/2010/main" val="0"/>
+                </a:ext>
+              </a:extLst>
+            </a:blip>
+            <a:srcRect/>
+            <a:stretch>
+              <a:fillRect/>
+            </a:stretch>
+          </a:blipFill>
+          <a:ln>
+            <a:noFill/>
+          </a:ln>
+        </p:spPr>
+        <p:style>
+          <a:lnRef idx="2">
+            <a:schemeClr val="accent1">
+              <a:shade val="15000"/>
+            </a:schemeClr>
+          </a:lnRef>
+          <a:fillRef idx="1">
+            <a:schemeClr val="accent1"/>
+          </a:fillRef>
+          <a:effectRef idx="0">
+            <a:schemeClr val="accent1"/>
+          </a:effectRef>
+          <a:fontRef idx="minor">
+            <a:schemeClr val="lt1"/>
+          </a:fontRef>
+        </p:style>
+        <p:txBody>
+          <a:bodyPr rtlCol="0" anchor="ctr"/>
+          <a:lstStyle/>
+          <a:p>
+            <a:pPr algn="ctr"/>
+            <a:endParaRPr lang="en-IN"/>
+          </a:p>
+        </p:txBody>
+      </p:sp>
+      <p:sp>
+        <p:nvSpPr>
+          <p:cNvPr id="3" name="Team B Logo">
+            <a:extLst>
+              <a:ext uri="{FF2B5EF4-FFF2-40B4-BE49-F238E27FC236}">
+                <a16:creationId xmlns:a16="http://schemas.microsoft.com/office/drawing/2014/main" id="{42DD75CE-B87B-A2AB-E9D6-A94D891FA961}"/>
+              </a:ext>
+            </a:extLst>
+          </p:cNvPr>
+          <p:cNvSpPr/>
+          <p:nvPr/>
+        </p:nvSpPr>
+        <p:spPr>
+          <a:xfrm>
+            <a:off x="-420986" y="3241443"/>
+            <a:ext cx="841972" cy="814509"/>
+          </a:xfrm>
+          <a:prstGeom prst="rect">
+            <a:avLst/>
+          </a:prstGeom>
+          <a:blipFill dpi="0" rotWithShape="1">
+            <a:blip r:embed="rId3">
+              <a:extLst>
+                <a:ext uri="{28A0092B-C50C-407E-A947-70E740481C1C}">
+                  <a14:useLocalDpi xmlns:a14="http://schemas.microsoft.com/office/drawing/2010/main" val="0"/>
+                </a:ext>
+              </a:extLst>
+            </a:blip>
+            <a:srcRect/>
+            <a:stretch>
+              <a:fillRect/>
+            </a:stretch>
+          </a:blipFill>
+          <a:ln>
+            <a:noFill/>
+          </a:ln>
+        </p:spPr>
+        <p:style>
+          <a:lnRef idx="2">
+            <a:schemeClr val="accent1">
+              <a:shade val="15000"/>
+            </a:schemeClr>
+          </a:lnRef>
+          <a:fillRef idx="1">
+            <a:schemeClr val="accent1"/>
+          </a:fillRef>
+          <a:effectRef idx="0">
+            <a:schemeClr val="accent1"/>
+          </a:effectRef>
+          <a:fontRef idx="minor">
+            <a:schemeClr val="lt1"/>
+          </a:fontRef>
+        </p:style>
+        <p:txBody>
+          <a:bodyPr rtlCol="0" anchor="ctr"/>
+          <a:lstStyle/>
+          <a:p>
+            <a:pPr algn="ctr"/>
+            <a:endParaRPr lang="en-IN"/>
+          </a:p>
+        </p:txBody>
+      </p:sp>
+      <p:grpSp>
+        <p:nvGrpSpPr>
+          <p:cNvPr id="12" name="Group 11">
+            <a:extLst>
+              <a:ext uri="{FF2B5EF4-FFF2-40B4-BE49-F238E27FC236}">
+                <a16:creationId xmlns:a16="http://schemas.microsoft.com/office/drawing/2014/main" id="{6E73F588-E744-219B-242D-94136B11BABD}"/>
+              </a:ext>
+            </a:extLst>
+          </p:cNvPr>
+          <p:cNvGrpSpPr/>
+          <p:nvPr/>
+        </p:nvGrpSpPr>
+        <p:grpSpPr>
+          <a:xfrm>
+            <a:off x="10092818" y="159766"/>
+            <a:ext cx="977638" cy="261610"/>
+            <a:chOff x="3759200" y="5085720"/>
+            <a:chExt cx="977638" cy="261610"/>
+          </a:xfrm>
+        </p:grpSpPr>
+        <p:sp>
+          <p:nvSpPr>
+            <p:cNvPr id="10" name="Rectangle 9">
+              <a:extLst>
+                <a:ext uri="{FF2B5EF4-FFF2-40B4-BE49-F238E27FC236}">
+                  <a16:creationId xmlns:a16="http://schemas.microsoft.com/office/drawing/2014/main" id="{6CC3860F-6365-EF4D-D168-C842F01149A9}"/>
+                </a:ext>
+              </a:extLst>
+            </p:cNvPr>
+            <p:cNvSpPr/>
+            <p:nvPr/>
+          </p:nvSpPr>
+          <p:spPr>
+            <a:xfrm>
+              <a:off x="3759200" y="5143500"/>
+              <a:ext cx="336550" cy="146050"/>
+            </a:xfrm>
+            <a:prstGeom prst="rect">
+              <a:avLst/>
+            </a:prstGeom>
+          </p:spPr>
+          <p:style>
+            <a:lnRef idx="2">
+              <a:schemeClr val="accent1">
+                <a:shade val="15000"/>
+              </a:schemeClr>
+            </a:lnRef>
+            <a:fillRef idx="1">
+              <a:schemeClr val="accent1"/>
+            </a:fillRef>
+            <a:effectRef idx="0">
+              <a:schemeClr val="accent1"/>
+            </a:effectRef>
+            <a:fontRef idx="minor">
+              <a:schemeClr val="lt1"/>
+            </a:fontRef>
+          </p:style>
+          <p:txBody>
+            <a:bodyPr rtlCol="0" anchor="ctr"/>
+            <a:lstStyle/>
+            <a:p>
+              <a:pPr algn="ctr"/>
+              <a:r>
+                <a:rPr lang="en-US" sz="800" dirty="0"/>
+                <a:t>CA</a:t>
+              </a:r>
+              <a:endParaRPr lang="en-IN" sz="800" dirty="0"/>
+            </a:p>
+          </p:txBody>
+        </p:sp>
+        <p:sp>
+          <p:nvSpPr>
+            <p:cNvPr id="11" name="TextBox 10">
+              <a:extLst>
+                <a:ext uri="{FF2B5EF4-FFF2-40B4-BE49-F238E27FC236}">
+                  <a16:creationId xmlns:a16="http://schemas.microsoft.com/office/drawing/2014/main" id="{E1149580-D805-5ABB-11D1-98485224CF6C}"/>
+                </a:ext>
+              </a:extLst>
+            </p:cNvPr>
+            <p:cNvSpPr txBox="1"/>
+            <p:nvPr/>
+          </p:nvSpPr>
+          <p:spPr>
+            <a:xfrm>
+              <a:off x="4140200" y="5085720"/>
+              <a:ext cx="596638" cy="261610"/>
+            </a:xfrm>
+            <a:prstGeom prst="rect">
+              <a:avLst/>
+            </a:prstGeom>
+            <a:noFill/>
+          </p:spPr>
+          <p:txBody>
+            <a:bodyPr wrap="none" rtlCol="0">
+              <a:spAutoFit/>
+            </a:bodyPr>
+            <a:lstStyle/>
+            <a:p>
+              <a:r>
+                <a:rPr lang="en-US" sz="1100" dirty="0"/>
+                <a:t>Testing</a:t>
+              </a:r>
+              <a:endParaRPr lang="en-IN" sz="1100" dirty="0"/>
+            </a:p>
+          </p:txBody>
+        </p:sp>
+      </p:grpSp>
+    </p:spTree>
+    <p:extLst>
+      <p:ext uri="{BB962C8B-B14F-4D97-AF65-F5344CB8AC3E}">
+        <p14:creationId xmlns:p14="http://schemas.microsoft.com/office/powerpoint/2010/main" val="4217125532"/>
       </p:ext>
     </p:extLst>
   </p:cSld>
@@ -6142,4 +9707,299 @@
     </a:ext>
   </a:extLst>
 </a:theme>
+</file>
+
+<file path=ppt/theme/theme2.xml><?xml version="1.0" encoding="utf-8"?>
+<a:theme xmlns:a="http://schemas.openxmlformats.org/drawingml/2006/main" name="Office Theme">
+  <a:themeElements>
+    <a:clrScheme name="Office">
+      <a:dk1>
+        <a:sysClr val="windowText" lastClr="000000"/>
+      </a:dk1>
+      <a:lt1>
+        <a:sysClr val="window" lastClr="FFFFFF"/>
+      </a:lt1>
+      <a:dk2>
+        <a:srgbClr val="44546A"/>
+      </a:dk2>
+      <a:lt2>
+        <a:srgbClr val="E7E6E6"/>
+      </a:lt2>
+      <a:accent1>
+        <a:srgbClr val="4472C4"/>
+      </a:accent1>
+      <a:accent2>
+        <a:srgbClr val="ED7D31"/>
+      </a:accent2>
+      <a:accent3>
+        <a:srgbClr val="A5A5A5"/>
+      </a:accent3>
+      <a:accent4>
+        <a:srgbClr val="FFC000"/>
+      </a:accent4>
+      <a:accent5>
+        <a:srgbClr val="5B9BD5"/>
+      </a:accent5>
+      <a:accent6>
+        <a:srgbClr val="70AD47"/>
+      </a:accent6>
+      <a:hlink>
+        <a:srgbClr val="0563C1"/>
+      </a:hlink>
+      <a:folHlink>
+        <a:srgbClr val="954F72"/>
+      </a:folHlink>
+    </a:clrScheme>
+    <a:fontScheme name="Office">
+      <a:majorFont>
+        <a:latin typeface="Calibri Light" panose="020F0302020204030204"/>
+        <a:ea typeface=""/>
+        <a:cs typeface=""/>
+        <a:font script="Jpan" typeface="游ゴシック Light"/>
+        <a:font script="Hang" typeface="맑은 고딕"/>
+        <a:font script="Hans" typeface="等线 Light"/>
+        <a:font script="Hant" typeface="新細明體"/>
+        <a:font script="Arab" typeface="Times New Roman"/>
+        <a:font script="Hebr" typeface="Times New Roman"/>
+        <a:font script="Thai" typeface="Angsana New"/>
+        <a:font script="Ethi" typeface="Nyala"/>
+        <a:font script="Beng" typeface="Vrinda"/>
+        <a:font script="Gujr" typeface="Shruti"/>
+        <a:font script="Khmr" typeface="MoolBoran"/>
+        <a:font script="Knda" typeface="Tunga"/>
+        <a:font script="Guru" typeface="Raavi"/>
+        <a:font script="Cans" typeface="Euphemia"/>
+        <a:font script="Cher" typeface="Plantagenet Cherokee"/>
+        <a:font script="Yiii" typeface="Microsoft Yi Baiti"/>
+        <a:font script="Tibt" typeface="Microsoft Himalaya"/>
+        <a:font script="Thaa" typeface="MV Boli"/>
+        <a:font script="Deva" typeface="Mangal"/>
+        <a:font script="Telu" typeface="Gautami"/>
+        <a:font script="Taml" typeface="Latha"/>
+        <a:font script="Syrc" typeface="Estrangelo Edessa"/>
+        <a:font script="Orya" typeface="Kalinga"/>
+        <a:font script="Mlym" typeface="Kartika"/>
+        <a:font script="Laoo" typeface="DokChampa"/>
+        <a:font script="Sinh" typeface="Iskoola Pota"/>
+        <a:font script="Mong" typeface="Mongolian Baiti"/>
+        <a:font script="Viet" typeface="Times New Roman"/>
+        <a:font script="Uigh" typeface="Microsoft Uighur"/>
+        <a:font script="Geor" typeface="Sylfaen"/>
+        <a:font script="Armn" typeface="Arial"/>
+        <a:font script="Bugi" typeface="Leelawadee UI"/>
+        <a:font script="Bopo" typeface="Microsoft JhengHei"/>
+        <a:font script="Java" typeface="Javanese Text"/>
+        <a:font script="Lisu" typeface="Segoe UI"/>
+        <a:font script="Mymr" typeface="Myanmar Text"/>
+        <a:font script="Nkoo" typeface="Ebrima"/>
+        <a:font script="Olck" typeface="Nirmala UI"/>
+        <a:font script="Osma" typeface="Ebrima"/>
+        <a:font script="Phag" typeface="Phagspa"/>
+        <a:font script="Syrn" typeface="Estrangelo Edessa"/>
+        <a:font script="Syrj" typeface="Estrangelo Edessa"/>
+        <a:font script="Syre" typeface="Estrangelo Edessa"/>
+        <a:font script="Sora" typeface="Nirmala UI"/>
+        <a:font script="Tale" typeface="Microsoft Tai Le"/>
+        <a:font script="Talu" typeface="Microsoft New Tai Lue"/>
+        <a:font script="Tfng" typeface="Ebrima"/>
+      </a:majorFont>
+      <a:minorFont>
+        <a:latin typeface="Calibri" panose="020F0502020204030204"/>
+        <a:ea typeface=""/>
+        <a:cs typeface=""/>
+        <a:font script="Jpan" typeface="游ゴシック"/>
+        <a:font script="Hang" typeface="맑은 고딕"/>
+        <a:font script="Hans" typeface="等线"/>
+        <a:font script="Hant" typeface="新細明體"/>
+        <a:font script="Arab" typeface="Arial"/>
+        <a:font script="Hebr" typeface="Arial"/>
+        <a:font script="Thai" typeface="Cordia New"/>
+        <a:font script="Ethi" typeface="Nyala"/>
+        <a:font script="Beng" typeface="Vrinda"/>
+        <a:font script="Gujr" typeface="Shruti"/>
+        <a:font script="Khmr" typeface="DaunPenh"/>
+        <a:font script="Knda" typeface="Tunga"/>
+        <a:font script="Guru" typeface="Raavi"/>
+        <a:font script="Cans" typeface="Euphemia"/>
+        <a:font script="Cher" typeface="Plantagenet Cherokee"/>
+        <a:font script="Yiii" typeface="Microsoft Yi Baiti"/>
+        <a:font script="Tibt" typeface="Microsoft Himalaya"/>
+        <a:font script="Thaa" typeface="MV Boli"/>
+        <a:font script="Deva" typeface="Mangal"/>
+        <a:font script="Telu" typeface="Gautami"/>
+        <a:font script="Taml" typeface="Latha"/>
+        <a:font script="Syrc" typeface="Estrangelo Edessa"/>
+        <a:font script="Orya" typeface="Kalinga"/>
+        <a:font script="Mlym" typeface="Kartika"/>
+        <a:font script="Laoo" typeface="DokChampa"/>
+        <a:font script="Sinh" typeface="Iskoola Pota"/>
+        <a:font script="Mong" typeface="Mongolian Baiti"/>
+        <a:font script="Viet" typeface="Arial"/>
+        <a:font script="Uigh" typeface="Microsoft Uighur"/>
+        <a:font script="Geor" typeface="Sylfaen"/>
+        <a:font script="Armn" typeface="Arial"/>
+        <a:font script="Bugi" typeface="Leelawadee UI"/>
+        <a:font script="Bopo" typeface="Microsoft JhengHei"/>
+        <a:font script="Java" typeface="Javanese Text"/>
+        <a:font script="Lisu" typeface="Segoe UI"/>
+        <a:font script="Mymr" typeface="Myanmar Text"/>
+        <a:font script="Nkoo" typeface="Ebrima"/>
+        <a:font script="Olck" typeface="Nirmala UI"/>
+        <a:font script="Osma" typeface="Ebrima"/>
+        <a:font script="Phag" typeface="Phagspa"/>
+        <a:font script="Syrn" typeface="Estrangelo Edessa"/>
+        <a:font script="Syrj" typeface="Estrangelo Edessa"/>
+        <a:font script="Syre" typeface="Estrangelo Edessa"/>
+        <a:font script="Sora" typeface="Nirmala UI"/>
+        <a:font script="Tale" typeface="Microsoft Tai Le"/>
+        <a:font script="Talu" typeface="Microsoft New Tai Lue"/>
+        <a:font script="Tfng" typeface="Ebrima"/>
+      </a:minorFont>
+    </a:fontScheme>
+    <a:fmtScheme name="Office">
+      <a:fillStyleLst>
+        <a:solidFill>
+          <a:schemeClr val="phClr"/>
+        </a:solidFill>
+        <a:gradFill rotWithShape="1">
+          <a:gsLst>
+            <a:gs pos="0">
+              <a:schemeClr val="phClr">
+                <a:lumMod val="110000"/>
+                <a:satMod val="105000"/>
+                <a:tint val="67000"/>
+              </a:schemeClr>
+            </a:gs>
+            <a:gs pos="50000">
+              <a:schemeClr val="phClr">
+                <a:lumMod val="105000"/>
+                <a:satMod val="103000"/>
+                <a:tint val="73000"/>
+              </a:schemeClr>
+            </a:gs>
+            <a:gs pos="100000">
+              <a:schemeClr val="phClr">
+                <a:lumMod val="105000"/>
+                <a:satMod val="109000"/>
+                <a:tint val="81000"/>
+              </a:schemeClr>
+            </a:gs>
+          </a:gsLst>
+          <a:lin ang="5400000" scaled="0"/>
+        </a:gradFill>
+        <a:gradFill rotWithShape="1">
+          <a:gsLst>
+            <a:gs pos="0">
+              <a:schemeClr val="phClr">
+                <a:satMod val="103000"/>
+                <a:lumMod val="102000"/>
+                <a:tint val="94000"/>
+              </a:schemeClr>
+            </a:gs>
+            <a:gs pos="50000">
+              <a:schemeClr val="phClr">
+                <a:satMod val="110000"/>
+                <a:lumMod val="100000"/>
+                <a:shade val="100000"/>
+              </a:schemeClr>
+            </a:gs>
+            <a:gs pos="100000">
+              <a:schemeClr val="phClr">
+                <a:lumMod val="99000"/>
+                <a:satMod val="120000"/>
+                <a:shade val="78000"/>
+              </a:schemeClr>
+            </a:gs>
+          </a:gsLst>
+          <a:lin ang="5400000" scaled="0"/>
+        </a:gradFill>
+      </a:fillStyleLst>
+      <a:lnStyleLst>
+        <a:ln w="6350" cap="flat" cmpd="sng" algn="ctr">
+          <a:solidFill>
+            <a:schemeClr val="phClr"/>
+          </a:solidFill>
+          <a:prstDash val="solid"/>
+          <a:miter lim="800000"/>
+        </a:ln>
+        <a:ln w="12700" cap="flat" cmpd="sng" algn="ctr">
+          <a:solidFill>
+            <a:schemeClr val="phClr"/>
+          </a:solidFill>
+          <a:prstDash val="solid"/>
+          <a:miter lim="800000"/>
+        </a:ln>
+        <a:ln w="19050" cap="flat" cmpd="sng" algn="ctr">
+          <a:solidFill>
+            <a:schemeClr val="phClr"/>
+          </a:solidFill>
+          <a:prstDash val="solid"/>
+          <a:miter lim="800000"/>
+        </a:ln>
+      </a:lnStyleLst>
+      <a:effectStyleLst>
+        <a:effectStyle>
+          <a:effectLst/>
+        </a:effectStyle>
+        <a:effectStyle>
+          <a:effectLst/>
+        </a:effectStyle>
+        <a:effectStyle>
+          <a:effectLst>
+            <a:outerShdw blurRad="57150" dist="19050" dir="5400000" algn="ctr" rotWithShape="0">
+              <a:srgbClr val="000000">
+                <a:alpha val="63000"/>
+              </a:srgbClr>
+            </a:outerShdw>
+          </a:effectLst>
+        </a:effectStyle>
+      </a:effectStyleLst>
+      <a:bgFillStyleLst>
+        <a:solidFill>
+          <a:schemeClr val="phClr"/>
+        </a:solidFill>
+        <a:solidFill>
+          <a:schemeClr val="phClr">
+            <a:tint val="95000"/>
+            <a:satMod val="170000"/>
+          </a:schemeClr>
+        </a:solidFill>
+        <a:gradFill rotWithShape="1">
+          <a:gsLst>
+            <a:gs pos="0">
+              <a:schemeClr val="phClr">
+                <a:tint val="93000"/>
+                <a:satMod val="150000"/>
+                <a:shade val="98000"/>
+                <a:lumMod val="102000"/>
+              </a:schemeClr>
+            </a:gs>
+            <a:gs pos="50000">
+              <a:schemeClr val="phClr">
+                <a:tint val="98000"/>
+                <a:satMod val="130000"/>
+                <a:shade val="90000"/>
+                <a:lumMod val="103000"/>
+              </a:schemeClr>
+            </a:gs>
+            <a:gs pos="100000">
+              <a:schemeClr val="phClr">
+                <a:shade val="63000"/>
+                <a:satMod val="120000"/>
+              </a:schemeClr>
+            </a:gs>
+          </a:gsLst>
+          <a:lin ang="5400000" scaled="0"/>
+        </a:gradFill>
+      </a:bgFillStyleLst>
+    </a:fmtScheme>
+  </a:themeElements>
+  <a:objectDefaults/>
+  <a:extraClrSchemeLst/>
+  <a:extLst>
+    <a:ext uri="{05A4C25C-085E-4340-85A3-A5531E510DB2}">
+      <thm15:themeFamily xmlns:thm15="http://schemas.microsoft.com/office/thememl/2012/main" name="Office Theme" id="{62F939B6-93AF-4DB8-9C6B-D6C7DFDC589F}" vid="{4A3C46E8-61CC-4603-A589-7422A47A8E4A}"/>
+    </a:ext>
+  </a:extLst>
+</a:theme>
 </file>
</xml_diff>